<commit_message>
chore(presentation): thêm slide lẻ, bộ logo và cập nhật số liệu deck
Đưa vào repo 3 bộ dựng slide lẻ (kiến trúc, đánh giá LLM, khảo sát người dùng)
cùng file pptx sinh ra và bộ logo - presentation/README.md đã mô tả chúng
nhưng file thì chưa được commit.

Deck dựng bằng code (phase 1) sửa 2 ô sai: "PostgreSQL / Neon" -> Supabase +
CockroachDB, "1.503 thuốc / 15.140 cặp" -> 1.939 hoạt chất / 160.227 cặp;
pitch_deck.pptx và speaker_notes_vi.md sinh lại theo generator.

Ghi rõ deck nộp cho BTC là docs/pitch-deck.pdf (bản phase 2, 17 trang), thư
mục này chỉ giữ file nguồn. pitch_deck.pdf phase 1 chưa export lại từ pptx.

Co-Authored-By: Claude Opus 5 <noreply@anthropic.com>
</commit_message>
<xml_diff>
--- a/presentation/pitch_deck.pptx
+++ b/presentation/pitch_deck.pptx
@@ -17,9 +17,10 @@
     <p:sldId id="265" r:id="rId11"/>
     <p:sldId id="266" r:id="rId12"/>
     <p:sldId id="267" r:id="rId13"/>
+    <p:sldId id="268" r:id="rId14"/>
   </p:sldIdLst>
   <p:notesMasterIdLst>
-    <p:notesMasterId r:id="rId14"/>
+    <p:notesMasterId r:id="rId15"/>
   </p:notesMasterIdLst>
   <p:sldSz cx="12192000" cy="6858000"/>
   <p:notesSz cx="6858000" cy="12192000"/>
@@ -689,7 +690,7 @@
           <a:p>
             <a:r>
               <a:rPr lang="en-US" dirty="0"/>
-              <a:t>Qua phân tích, sản phẩm có ba điểm mạnh: nguồn dữ liệu thật, trải nghiệm tiếng Việt và quy trình dược sĩ. Nhưng để đi tiếp, ưu tiên số một không phải thêm thật nhiều tính năng mà là đo lường, pilot với dược sĩ, hoàn thiện audit và bảo mật. Sau đó mới mở rộng OCR và mô hình kinh doanh.</a:t>
+              <a:t>Đợt đánh giá này đổi giám khảo từ DeepSeek-reasoner sang Claude để tránh việc AI tự chấm phiên bản anh em của chính nó, đồng thời rà soát kiến trúc và vá nhiều lỗi rò rỉ trước khi chấm diện rộng. Cả 3 chỉ số chất lượng chính đều đạt ngưỡng lần đầu tiên; điểm cần theo dõi tiếp là độ ổn định giữa các lần sinh.</a:t>
             </a:r>
             <a:endParaRPr lang="en-US" dirty="0"/>
           </a:p>
@@ -777,7 +778,7 @@
           <a:p>
             <a:r>
               <a:rPr lang="en-US" dirty="0"/>
-              <a:t>MediCheck hướng tới một nguyên tắc đơn giản: cảnh báo y tế không chỉ cần đúng, mà còn phải dễ hiểu, có nguồn và có người chịu trách nhiệm. Nhóm xin cảm ơn và sẵn sàng trả lời câu hỏi.</a:t>
+              <a:t>Qua phân tích, sản phẩm có ba điểm mạnh: nguồn dữ liệu thật, trải nghiệm tiếng Việt và quy trình dược sĩ. Nhưng để đi tiếp, ưu tiên số một không phải thêm thật nhiều tính năng mà là đo lường, pilot với dược sĩ, hoàn thiện audit và bảo mật. Sau đó mới mở rộng OCR và mô hình kinh doanh.</a:t>
             </a:r>
             <a:endParaRPr lang="en-US" dirty="0"/>
           </a:p>
@@ -801,6 +802,94 @@
             <a:fld id="{F7021451-1387-4CA6-816F-3879F97B5CBC}" type="slidenum">
               <a:rPr lang="en-US"/>
               <a:t>12</a:t>
+            </a:fld>
+            <a:endParaRPr lang="en-US"/>
+          </a:p>
+        </p:txBody>
+      </p:sp>
+    </p:spTree>
+    <p:extLst>
+      <p:ext uri="{BB962C8B-B14F-4D97-AF65-F5344CB8AC3E}">
+        <p14:creationId xmlns:p14="http://schemas.microsoft.com/office/powerpoint/2010/main" val="1024086991"/>
+      </p:ext>
+    </p:extLst>
+  </p:cSld>
+  <p:clrMapOvr>
+    <a:masterClrMapping/>
+  </p:clrMapOvr>
+</p:notes>
+</file>
+
+<file path=ppt/notesSlides/notesSlide13.xml><?xml version="1.0" encoding="utf-8"?>
+<p:notes xmlns:a="http://schemas.openxmlformats.org/drawingml/2006/main" xmlns:r="http://schemas.openxmlformats.org/officeDocument/2006/relationships" xmlns:p="http://schemas.openxmlformats.org/presentationml/2006/main">
+  <p:cSld>
+    <p:spTree>
+      <p:nvGrpSpPr>
+        <p:cNvPr id="1" name=""/>
+        <p:cNvGrpSpPr/>
+        <p:nvPr/>
+      </p:nvGrpSpPr>
+      <p:grpSpPr>
+        <a:xfrm>
+          <a:off x="0" y="0"/>
+          <a:ext cx="0" cy="0"/>
+          <a:chOff x="0" y="0"/>
+          <a:chExt cx="0" cy="0"/>
+        </a:xfrm>
+      </p:grpSpPr>
+      <p:sp>
+        <p:nvSpPr>
+          <p:cNvPr id="2" name="Slide Image Placeholder 1"/>
+          <p:cNvSpPr>
+            <a:spLocks noGrp="1" noRot="1" noChangeAspect="1"/>
+          </p:cNvSpPr>
+          <p:nvPr>
+            <p:ph type="sldImg"/>
+          </p:nvPr>
+        </p:nvSpPr>
+        <p:spPr/>
+      </p:sp>
+      <p:sp>
+        <p:nvSpPr>
+          <p:cNvPr id="3" name="Notes Placeholder 2"/>
+          <p:cNvSpPr>
+            <a:spLocks noGrp="1"/>
+          </p:cNvSpPr>
+          <p:nvPr>
+            <p:ph type="body" idx="1"/>
+          </p:nvPr>
+        </p:nvSpPr>
+        <p:spPr/>
+        <p:txBody>
+          <a:bodyPr/>
+          <a:lstStyle/>
+          <a:p>
+            <a:r>
+              <a:rPr lang="en-US" dirty="0"/>
+              <a:t>MediCheck hướng tới một nguyên tắc đơn giản: cảnh báo y tế không chỉ cần đúng, mà còn phải dễ hiểu, có nguồn và có người chịu trách nhiệm. Nhóm xin cảm ơn và sẵn sàng trả lời câu hỏi.</a:t>
+            </a:r>
+            <a:endParaRPr lang="en-US" dirty="0"/>
+          </a:p>
+        </p:txBody>
+      </p:sp>
+      <p:sp>
+        <p:nvSpPr>
+          <p:cNvPr id="4" name="Slide Number Placeholder 3"/>
+          <p:cNvSpPr>
+            <a:spLocks noGrp="1"/>
+          </p:cNvSpPr>
+          <p:nvPr>
+            <p:ph type="sldNum" sz="quarter" idx="10"/>
+          </p:nvPr>
+        </p:nvSpPr>
+        <p:spPr/>
+        <p:txBody>
+          <a:bodyPr/>
+          <a:lstStyle/>
+          <a:p>
+            <a:fld id="{F7021451-1387-4CA6-816F-3879F97B5CBC}" type="slidenum">
+              <a:rPr lang="en-US"/>
+              <a:t>13</a:t>
             </a:fld>
             <a:endParaRPr lang="en-US"/>
           </a:p>
@@ -2078,7 +2167,7 @@
       </p:sp>
       <p:pic>
         <p:nvPicPr>
-          <p:cNvPr id="3" name="Image 0" descr="C:\Users\admin\Documents\AITHUCHIEN\P-005\docs\screenshots\landing-page.png">    </p:cNvPr>
+          <p:cNvPr id="3" name="Image 0" descr="C:\Users\Quan\Documents\AIthucchien\Projects\P-005\docs\screenshots\landing-page.png">    </p:cNvPr>
           <p:cNvPicPr>
             <a:picLocks noChangeAspect="1"/>
           </p:cNvPicPr>
@@ -3486,7 +3575,7 @@
                 <a:ea typeface="Aptos" pitchFamily="34" charset="-122"/>
                 <a:cs typeface="Aptos" pitchFamily="34" charset="-120"/>
               </a:rPr>
-              <a:t>PostgreSQL / Neon</a:t>
+              <a:t>Supabase Postgres</a:t>
             </a:r>
             <a:endParaRPr lang="en-US" sz="1150" dirty="0"/>
           </a:p>
@@ -3506,7 +3595,7 @@
                 <a:ea typeface="Aptos" pitchFamily="34" charset="-122"/>
                 <a:cs typeface="Aptos" pitchFamily="34" charset="-120"/>
               </a:rPr>
-              <a:t>SQLite offline</a:t>
+              <a:t>CockroachDB (facts)</a:t>
             </a:r>
             <a:endParaRPr lang="en-US" sz="1150" dirty="0"/>
           </a:p>
@@ -4438,7 +4527,7 @@
                 <a:ea typeface="Aptos" pitchFamily="34" charset="-122"/>
                 <a:cs typeface="Aptos" pitchFamily="34" charset="-120"/>
               </a:rPr>
-              <a:t>10 / PHÂN TÍCH &amp; ĐỊNH HƯỚNG</a:t>
+              <a:t>08 / ĐÁNH GIÁ</a:t>
             </a:r>
             <a:endParaRPr lang="en-US" sz="1000" dirty="0"/>
           </a:p>
@@ -4482,7 +4571,7 @@
                 <a:ea typeface="Aptos" pitchFamily="34" charset="-122"/>
                 <a:cs typeface="Aptos" pitchFamily="34" charset="-120"/>
               </a:rPr>
-              <a:t>Nền tảng đúng hướng; bước tiếp theo là chứng minh chất lượng ngoài phòng lab</a:t>
+              <a:t>Đánh giá chất lượng giải thích AI — 3/3 chỉ số chính đạt ngưỡng</a:t>
             </a:r>
             <a:endParaRPr lang="en-US" sz="2700" dirty="0"/>
           </a:p>
@@ -4526,7 +4615,7 @@
                 <a:ea typeface="Aptos" pitchFamily="34" charset="-122"/>
                 <a:cs typeface="Aptos" pitchFamily="34" charset="-120"/>
               </a:rPr>
-              <a:t>Roadmap ưu tiên bằng chứng đo lường, độ tin cậy dữ liệu và khả năng vận hành trước khi mở rộng tính năng.</a:t>
+              <a:t>135 case thực tế, chấm bằng 24 phiên AI độc lập không cùng nhà cung cấp với model sinh nội dung — thay vì để AI tự chấm chính mình.</a:t>
             </a:r>
             <a:endParaRPr lang="en-US" sz="1250" dirty="0"/>
           </a:p>
@@ -4534,26 +4623,70 @@
       </p:sp>
       <p:sp>
         <p:nvSpPr>
-          <p:cNvPr id="5" name="Shape 3"/>
+          <p:cNvPr id="5" name="Text 3"/>
+          <p:cNvSpPr txBox="1"/>
+          <p:nvPr/>
+        </p:nvSpPr>
+        <p:spPr>
+          <a:xfrm>
+            <a:off x="530352" y="1700784"/>
+            <a:ext cx="2743200" cy="237744"/>
+          </a:xfrm>
+          <a:prstGeom prst="rect">
+            <a:avLst/>
+          </a:prstGeom>
+          <a:noFill/>
+          <a:ln/>
+        </p:spPr>
+        <p:txBody>
+          <a:bodyPr wrap="square" lIns="0" tIns="0" rIns="0" bIns="0" rtlCol="0" anchor="ctr">
+            <a:normAutofit/>
+          </a:bodyPr>
+          <a:lstStyle/>
+          <a:p>
+            <a:pPr algn="l" indent="0" marL="0">
+              <a:lnSpc>
+                <a:spcPct val="100000"/>
+              </a:lnSpc>
+              <a:buNone/>
+            </a:pPr>
+            <a:r>
+              <a:rPr lang="en-US" sz="1000" b="1" spc="130" kern="0" dirty="0">
+                <a:solidFill>
+                  <a:srgbClr val="4D73C9"/>
+                </a:solidFill>
+                <a:latin typeface="Aptos" pitchFamily="34" charset="0"/>
+                <a:ea typeface="Aptos" pitchFamily="34" charset="-122"/>
+                <a:cs typeface="Aptos" pitchFamily="34" charset="-120"/>
+              </a:rPr>
+              <a:t>SCORECARD</a:t>
+            </a:r>
+            <a:endParaRPr lang="en-US" sz="1000" dirty="0"/>
+          </a:p>
+        </p:txBody>
+      </p:sp>
+      <p:sp>
+        <p:nvSpPr>
+          <p:cNvPr id="6" name="Shape 4"/>
           <p:cNvSpPr/>
           <p:nvPr/>
         </p:nvSpPr>
         <p:spPr>
           <a:xfrm>
-            <a:off x="530352" y="1719072"/>
-            <a:ext cx="2505456" cy="1682496"/>
+            <a:off x="530352" y="1993392"/>
+            <a:ext cx="1748028" cy="1170432"/>
           </a:xfrm>
           <a:prstGeom prst="roundRect">
             <a:avLst>
-              <a:gd name="adj" fmla="val 9239"/>
+              <a:gd name="adj" fmla="val 12500"/>
             </a:avLst>
           </a:prstGeom>
           <a:solidFill>
-            <a:srgbClr val="000000"/>
+            <a:srgbClr val="E1F5EF"/>
           </a:solidFill>
           <a:ln w="12700">
             <a:solidFill>
-              <a:srgbClr val="333333"/>
+              <a:srgbClr val="E1F5EF"/>
             </a:solidFill>
             <a:prstDash val="solid"/>
           </a:ln>
@@ -4561,154 +4694,158 @@
       </p:sp>
       <p:sp>
         <p:nvSpPr>
-          <p:cNvPr id="6" name="Text 4"/>
-          <p:cNvSpPr txBox="1"/>
-          <p:nvPr/>
-        </p:nvSpPr>
-        <p:spPr>
-          <a:xfrm>
-            <a:off x="731520" y="1929384"/>
-            <a:ext cx="2103120" cy="246888"/>
-          </a:xfrm>
-          <a:prstGeom prst="rect">
-            <a:avLst/>
-          </a:prstGeom>
-          <a:noFill/>
-          <a:ln/>
-        </p:spPr>
-        <p:txBody>
-          <a:bodyPr wrap="square" lIns="0" tIns="0" rIns="0" bIns="0" rtlCol="0" anchor="ctr">
-            <a:normAutofit/>
-          </a:bodyPr>
-          <a:lstStyle/>
-          <a:p>
-            <a:pPr algn="ctr" indent="0" marL="0">
-              <a:lnSpc>
-                <a:spcPct val="100000"/>
-              </a:lnSpc>
-              <a:buNone/>
-            </a:pPr>
-            <a:r>
-              <a:rPr lang="en-US" sz="1020" b="1" spc="80" kern="0" dirty="0">
-                <a:solidFill>
-                  <a:srgbClr val="E1F5EF"/>
-                </a:solidFill>
-                <a:latin typeface="Aptos" pitchFamily="34" charset="0"/>
-                <a:ea typeface="Aptos" pitchFamily="34" charset="-122"/>
-                <a:cs typeface="Aptos" pitchFamily="34" charset="-120"/>
-              </a:rPr>
-              <a:t>ĐIỂM MẠNH</a:t>
-            </a:r>
-            <a:endParaRPr lang="en-US" sz="1020" dirty="0"/>
-          </a:p>
-        </p:txBody>
-      </p:sp>
-      <p:sp>
-        <p:nvSpPr>
           <p:cNvPr id="7" name="Text 5"/>
           <p:cNvSpPr txBox="1"/>
           <p:nvPr/>
         </p:nvSpPr>
         <p:spPr>
           <a:xfrm>
-            <a:off x="749808" y="2350008"/>
-            <a:ext cx="2066544" cy="786384"/>
-          </a:xfrm>
-          <a:prstGeom prst="rect">
-            <a:avLst/>
-          </a:prstGeom>
-          <a:noFill/>
-          <a:ln/>
-        </p:spPr>
-        <p:txBody>
-          <a:bodyPr wrap="square" lIns="0" tIns="0" rIns="0" bIns="0" rtlCol="0" anchor="t">
-            <a:normAutofit/>
-          </a:bodyPr>
-          <a:lstStyle/>
-          <a:p>
-            <a:pPr algn="ctr" indent="0" marL="0">
-              <a:lnSpc>
-                <a:spcPct val="100000"/>
-              </a:lnSpc>
-              <a:buNone/>
-            </a:pPr>
-            <a:r>
-              <a:rPr lang="en-US" sz="1050" dirty="0">
-                <a:solidFill>
-                  <a:srgbClr val="253B5F"/>
-                </a:solidFill>
-                <a:latin typeface="Aptos" pitchFamily="34" charset="0"/>
-                <a:ea typeface="Aptos" pitchFamily="34" charset="-122"/>
-                <a:cs typeface="Aptos" pitchFamily="34" charset="-120"/>
-              </a:rPr>
-              <a:t>Dữ liệu DDInter thật</a:t>
-            </a:r>
-            <a:endParaRPr lang="en-US" sz="1050" dirty="0"/>
-          </a:p>
-          <a:p>
-            <a:pPr algn="ctr" indent="0" marL="0">
-              <a:lnSpc>
-                <a:spcPct val="100000"/>
-              </a:lnSpc>
-              <a:buNone/>
-            </a:pPr>
-            <a:r>
-              <a:rPr lang="en-US" sz="1050" dirty="0">
-                <a:solidFill>
-                  <a:srgbClr val="253B5F"/>
-                </a:solidFill>
-                <a:latin typeface="Aptos" pitchFamily="34" charset="0"/>
-                <a:ea typeface="Aptos" pitchFamily="34" charset="-122"/>
-                <a:cs typeface="Aptos" pitchFamily="34" charset="-120"/>
-              </a:rPr>
-              <a:t>Giải thích tiếng Việt</a:t>
-            </a:r>
-            <a:endParaRPr lang="en-US" sz="1050" dirty="0"/>
-          </a:p>
-          <a:p>
-            <a:pPr algn="ctr" indent="0" marL="0">
-              <a:lnSpc>
-                <a:spcPct val="100000"/>
-              </a:lnSpc>
-              <a:buNone/>
-            </a:pPr>
-            <a:r>
-              <a:rPr lang="en-US" sz="1050" dirty="0">
-                <a:solidFill>
-                  <a:srgbClr val="253B5F"/>
-                </a:solidFill>
-                <a:latin typeface="Aptos" pitchFamily="34" charset="0"/>
-                <a:ea typeface="Aptos" pitchFamily="34" charset="-122"/>
-                <a:cs typeface="Aptos" pitchFamily="34" charset="-120"/>
-              </a:rPr>
-              <a:t>HITL dược sĩ</a:t>
-            </a:r>
-            <a:endParaRPr lang="en-US" sz="1050" dirty="0"/>
-          </a:p>
-        </p:txBody>
-      </p:sp>
-      <p:sp>
-        <p:nvSpPr>
-          <p:cNvPr id="8" name="Shape 6"/>
+            <a:off x="667512" y="2121408"/>
+            <a:ext cx="1473708" cy="457200"/>
+          </a:xfrm>
+          <a:prstGeom prst="rect">
+            <a:avLst/>
+          </a:prstGeom>
+          <a:noFill/>
+          <a:ln/>
+        </p:spPr>
+        <p:txBody>
+          <a:bodyPr wrap="square" lIns="0" tIns="0" rIns="0" bIns="0" rtlCol="0" anchor="ctr">
+            <a:normAutofit/>
+          </a:bodyPr>
+          <a:lstStyle/>
+          <a:p>
+            <a:pPr algn="l" indent="0" marL="0">
+              <a:lnSpc>
+                <a:spcPct val="100000"/>
+              </a:lnSpc>
+              <a:buNone/>
+            </a:pPr>
+            <a:r>
+              <a:rPr lang="en-US" sz="1900" b="1" dirty="0">
+                <a:solidFill>
+                  <a:srgbClr val="2C9A83"/>
+                </a:solidFill>
+                <a:latin typeface="Aptos" pitchFamily="34" charset="0"/>
+                <a:ea typeface="Aptos" pitchFamily="34" charset="-122"/>
+                <a:cs typeface="Aptos" pitchFamily="34" charset="-120"/>
+              </a:rPr>
+              <a:t>0.97</a:t>
+            </a:r>
+            <a:endParaRPr lang="en-US" sz="1900" dirty="0"/>
+          </a:p>
+        </p:txBody>
+      </p:sp>
+      <p:sp>
+        <p:nvSpPr>
+          <p:cNvPr id="8" name="Text 6"/>
+          <p:cNvSpPr txBox="1"/>
+          <p:nvPr/>
+        </p:nvSpPr>
+        <p:spPr>
+          <a:xfrm>
+            <a:off x="667512" y="2596896"/>
+            <a:ext cx="1473708" cy="292608"/>
+          </a:xfrm>
+          <a:prstGeom prst="rect">
+            <a:avLst/>
+          </a:prstGeom>
+          <a:noFill/>
+          <a:ln/>
+        </p:spPr>
+        <p:txBody>
+          <a:bodyPr wrap="square" lIns="0" tIns="0" rIns="0" bIns="0" rtlCol="0" anchor="ctr">
+            <a:normAutofit/>
+          </a:bodyPr>
+          <a:lstStyle/>
+          <a:p>
+            <a:pPr algn="l" indent="0" marL="0">
+              <a:lnSpc>
+                <a:spcPct val="100000"/>
+              </a:lnSpc>
+              <a:buNone/>
+            </a:pPr>
+            <a:r>
+              <a:rPr lang="en-US" sz="1000" b="1" dirty="0">
+                <a:solidFill>
+                  <a:srgbClr val="11284C"/>
+                </a:solidFill>
+                <a:latin typeface="Aptos" pitchFamily="34" charset="0"/>
+                <a:ea typeface="Aptos" pitchFamily="34" charset="-122"/>
+                <a:cs typeface="Aptos" pitchFamily="34" charset="-120"/>
+              </a:rPr>
+              <a:t>Faithfulness</a:t>
+            </a:r>
+            <a:endParaRPr lang="en-US" sz="1000" dirty="0"/>
+          </a:p>
+        </p:txBody>
+      </p:sp>
+      <p:sp>
+        <p:nvSpPr>
+          <p:cNvPr id="9" name="Text 7"/>
+          <p:cNvSpPr txBox="1"/>
+          <p:nvPr/>
+        </p:nvSpPr>
+        <p:spPr>
+          <a:xfrm>
+            <a:off x="667512" y="2880360"/>
+            <a:ext cx="1473708" cy="219456"/>
+          </a:xfrm>
+          <a:prstGeom prst="rect">
+            <a:avLst/>
+          </a:prstGeom>
+          <a:noFill/>
+          <a:ln/>
+        </p:spPr>
+        <p:txBody>
+          <a:bodyPr wrap="square" lIns="0" tIns="0" rIns="0" bIns="0" rtlCol="0" anchor="ctr">
+            <a:normAutofit/>
+          </a:bodyPr>
+          <a:lstStyle/>
+          <a:p>
+            <a:pPr algn="l" indent="0" marL="0">
+              <a:lnSpc>
+                <a:spcPct val="100000"/>
+              </a:lnSpc>
+              <a:buNone/>
+            </a:pPr>
+            <a:r>
+              <a:rPr lang="en-US" sz="840" dirty="0">
+                <a:solidFill>
+                  <a:srgbClr val="667792"/>
+                </a:solidFill>
+                <a:latin typeface="Aptos" pitchFamily="34" charset="0"/>
+                <a:ea typeface="Aptos" pitchFamily="34" charset="-122"/>
+                <a:cs typeface="Aptos" pitchFamily="34" charset="-120"/>
+              </a:rPr>
+              <a:t>≥ 0.95</a:t>
+            </a:r>
+            <a:endParaRPr lang="en-US" sz="840" dirty="0"/>
+          </a:p>
+        </p:txBody>
+      </p:sp>
+      <p:sp>
+        <p:nvSpPr>
+          <p:cNvPr id="10" name="Shape 8"/>
           <p:cNvSpPr/>
           <p:nvPr/>
         </p:nvSpPr>
         <p:spPr>
           <a:xfrm>
-            <a:off x="3319272" y="1719072"/>
-            <a:ext cx="2505456" cy="1682496"/>
+            <a:off x="2406396" y="1993392"/>
+            <a:ext cx="1748028" cy="1170432"/>
           </a:xfrm>
           <a:prstGeom prst="roundRect">
             <a:avLst>
-              <a:gd name="adj" fmla="val 9239"/>
+              <a:gd name="adj" fmla="val 12500"/>
             </a:avLst>
           </a:prstGeom>
           <a:solidFill>
-            <a:srgbClr val="000000"/>
+            <a:srgbClr val="E1F5EF"/>
           </a:solidFill>
           <a:ln w="12700">
             <a:solidFill>
-              <a:srgbClr val="333333"/>
+              <a:srgbClr val="E1F5EF"/>
             </a:solidFill>
             <a:prstDash val="solid"/>
           </a:ln>
@@ -4716,154 +4853,158 @@
       </p:sp>
       <p:sp>
         <p:nvSpPr>
-          <p:cNvPr id="9" name="Text 7"/>
-          <p:cNvSpPr txBox="1"/>
-          <p:nvPr/>
-        </p:nvSpPr>
-        <p:spPr>
-          <a:xfrm>
-            <a:off x="3520440" y="1929384"/>
-            <a:ext cx="2103120" cy="246888"/>
-          </a:xfrm>
-          <a:prstGeom prst="rect">
-            <a:avLst/>
-          </a:prstGeom>
-          <a:noFill/>
-          <a:ln/>
-        </p:spPr>
-        <p:txBody>
-          <a:bodyPr wrap="square" lIns="0" tIns="0" rIns="0" bIns="0" rtlCol="0" anchor="ctr">
-            <a:normAutofit/>
-          </a:bodyPr>
-          <a:lstStyle/>
-          <a:p>
-            <a:pPr algn="ctr" indent="0" marL="0">
-              <a:lnSpc>
-                <a:spcPct val="100000"/>
-              </a:lnSpc>
-              <a:buNone/>
-            </a:pPr>
-            <a:r>
-              <a:rPr lang="en-US" sz="1020" b="1" spc="80" kern="0" dirty="0">
-                <a:solidFill>
-                  <a:srgbClr val="FFE5E2"/>
-                </a:solidFill>
-                <a:latin typeface="Aptos" pitchFamily="34" charset="0"/>
-                <a:ea typeface="Aptos" pitchFamily="34" charset="-122"/>
-                <a:cs typeface="Aptos" pitchFamily="34" charset="-120"/>
-              </a:rPr>
-              <a:t>ĐIỂM YẾU</a:t>
-            </a:r>
-            <a:endParaRPr lang="en-US" sz="1020" dirty="0"/>
-          </a:p>
-        </p:txBody>
-      </p:sp>
-      <p:sp>
-        <p:nvSpPr>
-          <p:cNvPr id="10" name="Text 8"/>
-          <p:cNvSpPr txBox="1"/>
-          <p:nvPr/>
-        </p:nvSpPr>
-        <p:spPr>
-          <a:xfrm>
-            <a:off x="3538728" y="2350008"/>
-            <a:ext cx="2066544" cy="786384"/>
-          </a:xfrm>
-          <a:prstGeom prst="rect">
-            <a:avLst/>
-          </a:prstGeom>
-          <a:noFill/>
-          <a:ln/>
-        </p:spPr>
-        <p:txBody>
-          <a:bodyPr wrap="square" lIns="0" tIns="0" rIns="0" bIns="0" rtlCol="0" anchor="t">
-            <a:normAutofit/>
-          </a:bodyPr>
-          <a:lstStyle/>
-          <a:p>
-            <a:pPr algn="ctr" indent="0" marL="0">
-              <a:lnSpc>
-                <a:spcPct val="100000"/>
-              </a:lnSpc>
-              <a:buNone/>
-            </a:pPr>
-            <a:r>
-              <a:rPr lang="en-US" sz="1050" dirty="0">
-                <a:solidFill>
-                  <a:srgbClr val="253B5F"/>
-                </a:solidFill>
-                <a:latin typeface="Aptos" pitchFamily="34" charset="0"/>
-                <a:ea typeface="Aptos" pitchFamily="34" charset="-122"/>
-                <a:cs typeface="Aptos" pitchFamily="34" charset="-120"/>
-              </a:rPr>
-              <a:t>KPI chưa đo đủ</a:t>
-            </a:r>
-            <a:endParaRPr lang="en-US" sz="1050" dirty="0"/>
-          </a:p>
-          <a:p>
-            <a:pPr algn="ctr" indent="0" marL="0">
-              <a:lnSpc>
-                <a:spcPct val="100000"/>
-              </a:lnSpc>
-              <a:buNone/>
-            </a:pPr>
-            <a:r>
-              <a:rPr lang="en-US" sz="1050" dirty="0">
-                <a:solidFill>
-                  <a:srgbClr val="253B5F"/>
-                </a:solidFill>
-                <a:latin typeface="Aptos" pitchFamily="34" charset="0"/>
-                <a:ea typeface="Aptos" pitchFamily="34" charset="-122"/>
-                <a:cs typeface="Aptos" pitchFamily="34" charset="-120"/>
-              </a:rPr>
-              <a:t>Phụ thuộc dịch vụ LLM</a:t>
-            </a:r>
-            <a:endParaRPr lang="en-US" sz="1050" dirty="0"/>
-          </a:p>
-          <a:p>
-            <a:pPr algn="ctr" indent="0" marL="0">
-              <a:lnSpc>
-                <a:spcPct val="100000"/>
-              </a:lnSpc>
-              <a:buNone/>
-            </a:pPr>
-            <a:r>
-              <a:rPr lang="en-US" sz="1050" dirty="0">
-                <a:solidFill>
-                  <a:srgbClr val="253B5F"/>
-                </a:solidFill>
-                <a:latin typeface="Aptos" pitchFamily="34" charset="0"/>
-                <a:ea typeface="Aptos" pitchFamily="34" charset="-122"/>
-                <a:cs typeface="Aptos" pitchFamily="34" charset="-120"/>
-              </a:rPr>
-              <a:t>Dữ liệu y tế nhạy cảm</a:t>
-            </a:r>
-            <a:endParaRPr lang="en-US" sz="1050" dirty="0"/>
-          </a:p>
-        </p:txBody>
-      </p:sp>
-      <p:sp>
-        <p:nvSpPr>
-          <p:cNvPr id="11" name="Shape 9"/>
+          <p:cNvPr id="11" name="Text 9"/>
+          <p:cNvSpPr txBox="1"/>
+          <p:nvPr/>
+        </p:nvSpPr>
+        <p:spPr>
+          <a:xfrm>
+            <a:off x="2543556" y="2121408"/>
+            <a:ext cx="1473708" cy="457200"/>
+          </a:xfrm>
+          <a:prstGeom prst="rect">
+            <a:avLst/>
+          </a:prstGeom>
+          <a:noFill/>
+          <a:ln/>
+        </p:spPr>
+        <p:txBody>
+          <a:bodyPr wrap="square" lIns="0" tIns="0" rIns="0" bIns="0" rtlCol="0" anchor="ctr">
+            <a:normAutofit/>
+          </a:bodyPr>
+          <a:lstStyle/>
+          <a:p>
+            <a:pPr algn="l" indent="0" marL="0">
+              <a:lnSpc>
+                <a:spcPct val="100000"/>
+              </a:lnSpc>
+              <a:buNone/>
+            </a:pPr>
+            <a:r>
+              <a:rPr lang="en-US" sz="1900" b="1" dirty="0">
+                <a:solidFill>
+                  <a:srgbClr val="2C9A83"/>
+                </a:solidFill>
+                <a:latin typeface="Aptos" pitchFamily="34" charset="0"/>
+                <a:ea typeface="Aptos" pitchFamily="34" charset="-122"/>
+                <a:cs typeface="Aptos" pitchFamily="34" charset="-120"/>
+              </a:rPr>
+              <a:t>4.67</a:t>
+            </a:r>
+            <a:endParaRPr lang="en-US" sz="1900" dirty="0"/>
+          </a:p>
+        </p:txBody>
+      </p:sp>
+      <p:sp>
+        <p:nvSpPr>
+          <p:cNvPr id="12" name="Text 10"/>
+          <p:cNvSpPr txBox="1"/>
+          <p:nvPr/>
+        </p:nvSpPr>
+        <p:spPr>
+          <a:xfrm>
+            <a:off x="2543556" y="2596896"/>
+            <a:ext cx="1473708" cy="292608"/>
+          </a:xfrm>
+          <a:prstGeom prst="rect">
+            <a:avLst/>
+          </a:prstGeom>
+          <a:noFill/>
+          <a:ln/>
+        </p:spPr>
+        <p:txBody>
+          <a:bodyPr wrap="square" lIns="0" tIns="0" rIns="0" bIns="0" rtlCol="0" anchor="ctr">
+            <a:normAutofit/>
+          </a:bodyPr>
+          <a:lstStyle/>
+          <a:p>
+            <a:pPr algn="l" indent="0" marL="0">
+              <a:lnSpc>
+                <a:spcPct val="100000"/>
+              </a:lnSpc>
+              <a:buNone/>
+            </a:pPr>
+            <a:r>
+              <a:rPr lang="en-US" sz="1000" b="1" dirty="0">
+                <a:solidFill>
+                  <a:srgbClr val="11284C"/>
+                </a:solidFill>
+                <a:latin typeface="Aptos" pitchFamily="34" charset="0"/>
+                <a:ea typeface="Aptos" pitchFamily="34" charset="-122"/>
+                <a:cs typeface="Aptos" pitchFamily="34" charset="-120"/>
+              </a:rPr>
+              <a:t>Relevance /5</a:t>
+            </a:r>
+            <a:endParaRPr lang="en-US" sz="1000" dirty="0"/>
+          </a:p>
+        </p:txBody>
+      </p:sp>
+      <p:sp>
+        <p:nvSpPr>
+          <p:cNvPr id="13" name="Text 11"/>
+          <p:cNvSpPr txBox="1"/>
+          <p:nvPr/>
+        </p:nvSpPr>
+        <p:spPr>
+          <a:xfrm>
+            <a:off x="2543556" y="2880360"/>
+            <a:ext cx="1473708" cy="219456"/>
+          </a:xfrm>
+          <a:prstGeom prst="rect">
+            <a:avLst/>
+          </a:prstGeom>
+          <a:noFill/>
+          <a:ln/>
+        </p:spPr>
+        <p:txBody>
+          <a:bodyPr wrap="square" lIns="0" tIns="0" rIns="0" bIns="0" rtlCol="0" anchor="ctr">
+            <a:normAutofit/>
+          </a:bodyPr>
+          <a:lstStyle/>
+          <a:p>
+            <a:pPr algn="l" indent="0" marL="0">
+              <a:lnSpc>
+                <a:spcPct val="100000"/>
+              </a:lnSpc>
+              <a:buNone/>
+            </a:pPr>
+            <a:r>
+              <a:rPr lang="en-US" sz="840" dirty="0">
+                <a:solidFill>
+                  <a:srgbClr val="667792"/>
+                </a:solidFill>
+                <a:latin typeface="Aptos" pitchFamily="34" charset="0"/>
+                <a:ea typeface="Aptos" pitchFamily="34" charset="-122"/>
+                <a:cs typeface="Aptos" pitchFamily="34" charset="-120"/>
+              </a:rPr>
+              <a:t>≥ 4.3</a:t>
+            </a:r>
+            <a:endParaRPr lang="en-US" sz="840" dirty="0"/>
+          </a:p>
+        </p:txBody>
+      </p:sp>
+      <p:sp>
+        <p:nvSpPr>
+          <p:cNvPr id="14" name="Shape 12"/>
           <p:cNvSpPr/>
           <p:nvPr/>
         </p:nvSpPr>
         <p:spPr>
           <a:xfrm>
-            <a:off x="6108192" y="1719072"/>
-            <a:ext cx="2505456" cy="1682496"/>
+            <a:off x="4282440" y="1993392"/>
+            <a:ext cx="1748028" cy="1170432"/>
           </a:xfrm>
           <a:prstGeom prst="roundRect">
             <a:avLst>
-              <a:gd name="adj" fmla="val 9239"/>
+              <a:gd name="adj" fmla="val 12500"/>
             </a:avLst>
           </a:prstGeom>
           <a:solidFill>
-            <a:srgbClr val="000000"/>
+            <a:srgbClr val="E1F5EF"/>
           </a:solidFill>
           <a:ln w="12700">
             <a:solidFill>
-              <a:srgbClr val="333333"/>
+              <a:srgbClr val="E1F5EF"/>
             </a:solidFill>
             <a:prstDash val="solid"/>
           </a:ln>
@@ -4871,154 +5012,158 @@
       </p:sp>
       <p:sp>
         <p:nvSpPr>
-          <p:cNvPr id="12" name="Text 10"/>
-          <p:cNvSpPr txBox="1"/>
-          <p:nvPr/>
-        </p:nvSpPr>
-        <p:spPr>
-          <a:xfrm>
-            <a:off x="6309360" y="1929384"/>
-            <a:ext cx="2103120" cy="246888"/>
-          </a:xfrm>
-          <a:prstGeom prst="rect">
-            <a:avLst/>
-          </a:prstGeom>
-          <a:noFill/>
-          <a:ln/>
-        </p:spPr>
-        <p:txBody>
-          <a:bodyPr wrap="square" lIns="0" tIns="0" rIns="0" bIns="0" rtlCol="0" anchor="ctr">
-            <a:normAutofit/>
-          </a:bodyPr>
-          <a:lstStyle/>
-          <a:p>
-            <a:pPr algn="ctr" indent="0" marL="0">
-              <a:lnSpc>
-                <a:spcPct val="100000"/>
-              </a:lnSpc>
-              <a:buNone/>
-            </a:pPr>
-            <a:r>
-              <a:rPr lang="en-US" sz="1020" b="1" spc="80" kern="0" dirty="0">
-                <a:solidFill>
-                  <a:srgbClr val="E9F0FF"/>
-                </a:solidFill>
-                <a:latin typeface="Aptos" pitchFamily="34" charset="0"/>
-                <a:ea typeface="Aptos" pitchFamily="34" charset="-122"/>
-                <a:cs typeface="Aptos" pitchFamily="34" charset="-120"/>
-              </a:rPr>
-              <a:t>CƠ HỘI</a:t>
-            </a:r>
-            <a:endParaRPr lang="en-US" sz="1020" dirty="0"/>
-          </a:p>
-        </p:txBody>
-      </p:sp>
-      <p:sp>
-        <p:nvSpPr>
-          <p:cNvPr id="13" name="Text 11"/>
-          <p:cNvSpPr txBox="1"/>
-          <p:nvPr/>
-        </p:nvSpPr>
-        <p:spPr>
-          <a:xfrm>
-            <a:off x="6327648" y="2350008"/>
-            <a:ext cx="2066544" cy="786384"/>
-          </a:xfrm>
-          <a:prstGeom prst="rect">
-            <a:avLst/>
-          </a:prstGeom>
-          <a:noFill/>
-          <a:ln/>
-        </p:spPr>
-        <p:txBody>
-          <a:bodyPr wrap="square" lIns="0" tIns="0" rIns="0" bIns="0" rtlCol="0" anchor="t">
-            <a:normAutofit/>
-          </a:bodyPr>
-          <a:lstStyle/>
-          <a:p>
-            <a:pPr algn="ctr" indent="0" marL="0">
-              <a:lnSpc>
-                <a:spcPct val="100000"/>
-              </a:lnSpc>
-              <a:buNone/>
-            </a:pPr>
-            <a:r>
-              <a:rPr lang="en-US" sz="1050" dirty="0">
-                <a:solidFill>
-                  <a:srgbClr val="253B5F"/>
-                </a:solidFill>
-                <a:latin typeface="Aptos" pitchFamily="34" charset="0"/>
-                <a:ea typeface="Aptos" pitchFamily="34" charset="-122"/>
-                <a:cs typeface="Aptos" pitchFamily="34" charset="-120"/>
-              </a:rPr>
-              <a:t>Nhà thuốc / phòng khám nhỏ</a:t>
-            </a:r>
-            <a:endParaRPr lang="en-US" sz="1050" dirty="0"/>
-          </a:p>
-          <a:p>
-            <a:pPr algn="ctr" indent="0" marL="0">
-              <a:lnSpc>
-                <a:spcPct val="100000"/>
-              </a:lnSpc>
-              <a:buNone/>
-            </a:pPr>
-            <a:r>
-              <a:rPr lang="en-US" sz="1050" dirty="0">
-                <a:solidFill>
-                  <a:srgbClr val="253B5F"/>
-                </a:solidFill>
-                <a:latin typeface="Aptos" pitchFamily="34" charset="0"/>
-                <a:ea typeface="Aptos" pitchFamily="34" charset="-122"/>
-                <a:cs typeface="Aptos" pitchFamily="34" charset="-120"/>
-              </a:rPr>
-              <a:t>Người dùng đa bệnh lý</a:t>
-            </a:r>
-            <a:endParaRPr lang="en-US" sz="1050" dirty="0"/>
-          </a:p>
-          <a:p>
-            <a:pPr algn="ctr" indent="0" marL="0">
-              <a:lnSpc>
-                <a:spcPct val="100000"/>
-              </a:lnSpc>
-              <a:buNone/>
-            </a:pPr>
-            <a:r>
-              <a:rPr lang="en-US" sz="1050" dirty="0">
-                <a:solidFill>
-                  <a:srgbClr val="253B5F"/>
-                </a:solidFill>
-                <a:latin typeface="Aptos" pitchFamily="34" charset="0"/>
-                <a:ea typeface="Aptos" pitchFamily="34" charset="-122"/>
-                <a:cs typeface="Aptos" pitchFamily="34" charset="-120"/>
-              </a:rPr>
-              <a:t>OCR đơn thuốc</a:t>
-            </a:r>
-            <a:endParaRPr lang="en-US" sz="1050" dirty="0"/>
-          </a:p>
-        </p:txBody>
-      </p:sp>
-      <p:sp>
-        <p:nvSpPr>
-          <p:cNvPr id="14" name="Shape 12"/>
+          <p:cNvPr id="15" name="Text 13"/>
+          <p:cNvSpPr txBox="1"/>
+          <p:nvPr/>
+        </p:nvSpPr>
+        <p:spPr>
+          <a:xfrm>
+            <a:off x="4419600" y="2121408"/>
+            <a:ext cx="1473708" cy="457200"/>
+          </a:xfrm>
+          <a:prstGeom prst="rect">
+            <a:avLst/>
+          </a:prstGeom>
+          <a:noFill/>
+          <a:ln/>
+        </p:spPr>
+        <p:txBody>
+          <a:bodyPr wrap="square" lIns="0" tIns="0" rIns="0" bIns="0" rtlCol="0" anchor="ctr">
+            <a:normAutofit/>
+          </a:bodyPr>
+          <a:lstStyle/>
+          <a:p>
+            <a:pPr algn="l" indent="0" marL="0">
+              <a:lnSpc>
+                <a:spcPct val="100000"/>
+              </a:lnSpc>
+              <a:buNone/>
+            </a:pPr>
+            <a:r>
+              <a:rPr lang="en-US" sz="1900" b="1" dirty="0">
+                <a:solidFill>
+                  <a:srgbClr val="2C9A83"/>
+                </a:solidFill>
+                <a:latin typeface="Aptos" pitchFamily="34" charset="0"/>
+                <a:ea typeface="Aptos" pitchFamily="34" charset="-122"/>
+                <a:cs typeface="Aptos" pitchFamily="34" charset="-120"/>
+              </a:rPr>
+              <a:t>1.00</a:t>
+            </a:r>
+            <a:endParaRPr lang="en-US" sz="1900" dirty="0"/>
+          </a:p>
+        </p:txBody>
+      </p:sp>
+      <p:sp>
+        <p:nvSpPr>
+          <p:cNvPr id="16" name="Text 14"/>
+          <p:cNvSpPr txBox="1"/>
+          <p:nvPr/>
+        </p:nvSpPr>
+        <p:spPr>
+          <a:xfrm>
+            <a:off x="4419600" y="2596896"/>
+            <a:ext cx="1473708" cy="292608"/>
+          </a:xfrm>
+          <a:prstGeom prst="rect">
+            <a:avLst/>
+          </a:prstGeom>
+          <a:noFill/>
+          <a:ln/>
+        </p:spPr>
+        <p:txBody>
+          <a:bodyPr wrap="square" lIns="0" tIns="0" rIns="0" bIns="0" rtlCol="0" anchor="ctr">
+            <a:normAutofit/>
+          </a:bodyPr>
+          <a:lstStyle/>
+          <a:p>
+            <a:pPr algn="l" indent="0" marL="0">
+              <a:lnSpc>
+                <a:spcPct val="100000"/>
+              </a:lnSpc>
+              <a:buNone/>
+            </a:pPr>
+            <a:r>
+              <a:rPr lang="en-US" sz="1000" b="1" dirty="0">
+                <a:solidFill>
+                  <a:srgbClr val="11284C"/>
+                </a:solidFill>
+                <a:latin typeface="Aptos" pitchFamily="34" charset="0"/>
+                <a:ea typeface="Aptos" pitchFamily="34" charset="-122"/>
+                <a:cs typeface="Aptos" pitchFamily="34" charset="-120"/>
+              </a:rPr>
+              <a:t>Completeness</a:t>
+            </a:r>
+            <a:endParaRPr lang="en-US" sz="1000" dirty="0"/>
+          </a:p>
+        </p:txBody>
+      </p:sp>
+      <p:sp>
+        <p:nvSpPr>
+          <p:cNvPr id="17" name="Text 15"/>
+          <p:cNvSpPr txBox="1"/>
+          <p:nvPr/>
+        </p:nvSpPr>
+        <p:spPr>
+          <a:xfrm>
+            <a:off x="4419600" y="2880360"/>
+            <a:ext cx="1473708" cy="219456"/>
+          </a:xfrm>
+          <a:prstGeom prst="rect">
+            <a:avLst/>
+          </a:prstGeom>
+          <a:noFill/>
+          <a:ln/>
+        </p:spPr>
+        <p:txBody>
+          <a:bodyPr wrap="square" lIns="0" tIns="0" rIns="0" bIns="0" rtlCol="0" anchor="ctr">
+            <a:normAutofit/>
+          </a:bodyPr>
+          <a:lstStyle/>
+          <a:p>
+            <a:pPr algn="l" indent="0" marL="0">
+              <a:lnSpc>
+                <a:spcPct val="100000"/>
+              </a:lnSpc>
+              <a:buNone/>
+            </a:pPr>
+            <a:r>
+              <a:rPr lang="en-US" sz="840" dirty="0">
+                <a:solidFill>
+                  <a:srgbClr val="667792"/>
+                </a:solidFill>
+                <a:latin typeface="Aptos" pitchFamily="34" charset="0"/>
+                <a:ea typeface="Aptos" pitchFamily="34" charset="-122"/>
+                <a:cs typeface="Aptos" pitchFamily="34" charset="-120"/>
+              </a:rPr>
+              <a:t>≥ 0.90</a:t>
+            </a:r>
+            <a:endParaRPr lang="en-US" sz="840" dirty="0"/>
+          </a:p>
+        </p:txBody>
+      </p:sp>
+      <p:sp>
+        <p:nvSpPr>
+          <p:cNvPr id="18" name="Shape 16"/>
           <p:cNvSpPr/>
           <p:nvPr/>
         </p:nvSpPr>
         <p:spPr>
           <a:xfrm>
-            <a:off x="8897112" y="1719072"/>
-            <a:ext cx="2505456" cy="1682496"/>
+            <a:off x="6158484" y="1993392"/>
+            <a:ext cx="1748028" cy="1170432"/>
           </a:xfrm>
           <a:prstGeom prst="roundRect">
             <a:avLst>
-              <a:gd name="adj" fmla="val 9239"/>
+              <a:gd name="adj" fmla="val 12500"/>
             </a:avLst>
           </a:prstGeom>
           <a:solidFill>
-            <a:srgbClr val="000000"/>
+            <a:srgbClr val="E1F5EF"/>
           </a:solidFill>
           <a:ln w="12700">
             <a:solidFill>
-              <a:srgbClr val="333333"/>
+              <a:srgbClr val="E1F5EF"/>
             </a:solidFill>
             <a:prstDash val="solid"/>
           </a:ln>
@@ -5026,142 +5171,14 @@
       </p:sp>
       <p:sp>
         <p:nvSpPr>
-          <p:cNvPr id="15" name="Text 13"/>
-          <p:cNvSpPr txBox="1"/>
-          <p:nvPr/>
-        </p:nvSpPr>
-        <p:spPr>
-          <a:xfrm>
-            <a:off x="9098280" y="1929384"/>
-            <a:ext cx="2103120" cy="246888"/>
-          </a:xfrm>
-          <a:prstGeom prst="rect">
-            <a:avLst/>
-          </a:prstGeom>
-          <a:noFill/>
-          <a:ln/>
-        </p:spPr>
-        <p:txBody>
-          <a:bodyPr wrap="square" lIns="0" tIns="0" rIns="0" bIns="0" rtlCol="0" anchor="ctr">
-            <a:normAutofit/>
-          </a:bodyPr>
-          <a:lstStyle/>
-          <a:p>
-            <a:pPr algn="ctr" indent="0" marL="0">
-              <a:lnSpc>
-                <a:spcPct val="100000"/>
-              </a:lnSpc>
-              <a:buNone/>
-            </a:pPr>
-            <a:r>
-              <a:rPr lang="en-US" sz="1020" b="1" spc="80" kern="0" dirty="0">
-                <a:solidFill>
-                  <a:srgbClr val="FFF1D9"/>
-                </a:solidFill>
-                <a:latin typeface="Aptos" pitchFamily="34" charset="0"/>
-                <a:ea typeface="Aptos" pitchFamily="34" charset="-122"/>
-                <a:cs typeface="Aptos" pitchFamily="34" charset="-120"/>
-              </a:rPr>
-              <a:t>THÁCH THỨC</a:t>
-            </a:r>
-            <a:endParaRPr lang="en-US" sz="1020" dirty="0"/>
-          </a:p>
-        </p:txBody>
-      </p:sp>
-      <p:sp>
-        <p:nvSpPr>
-          <p:cNvPr id="16" name="Text 14"/>
-          <p:cNvSpPr txBox="1"/>
-          <p:nvPr/>
-        </p:nvSpPr>
-        <p:spPr>
-          <a:xfrm>
-            <a:off x="9116568" y="2350008"/>
-            <a:ext cx="2066544" cy="786384"/>
-          </a:xfrm>
-          <a:prstGeom prst="rect">
-            <a:avLst/>
-          </a:prstGeom>
-          <a:noFill/>
-          <a:ln/>
-        </p:spPr>
-        <p:txBody>
-          <a:bodyPr wrap="square" lIns="0" tIns="0" rIns="0" bIns="0" rtlCol="0" anchor="t">
-            <a:normAutofit/>
-          </a:bodyPr>
-          <a:lstStyle/>
-          <a:p>
-            <a:pPr algn="ctr" indent="0" marL="0">
-              <a:lnSpc>
-                <a:spcPct val="100000"/>
-              </a:lnSpc>
-              <a:buNone/>
-            </a:pPr>
-            <a:r>
-              <a:rPr lang="en-US" sz="1050" dirty="0">
-                <a:solidFill>
-                  <a:srgbClr val="253B5F"/>
-                </a:solidFill>
-                <a:latin typeface="Aptos" pitchFamily="34" charset="0"/>
-                <a:ea typeface="Aptos" pitchFamily="34" charset="-122"/>
-                <a:cs typeface="Aptos" pitchFamily="34" charset="-120"/>
-              </a:rPr>
-              <a:t>Niềm tin &amp; pháp lý</a:t>
-            </a:r>
-            <a:endParaRPr lang="en-US" sz="1050" dirty="0"/>
-          </a:p>
-          <a:p>
-            <a:pPr algn="ctr" indent="0" marL="0">
-              <a:lnSpc>
-                <a:spcPct val="100000"/>
-              </a:lnSpc>
-              <a:buNone/>
-            </a:pPr>
-            <a:r>
-              <a:rPr lang="en-US" sz="1050" dirty="0">
-                <a:solidFill>
-                  <a:srgbClr val="253B5F"/>
-                </a:solidFill>
-                <a:latin typeface="Aptos" pitchFamily="34" charset="0"/>
-                <a:ea typeface="Aptos" pitchFamily="34" charset="-122"/>
-                <a:cs typeface="Aptos" pitchFamily="34" charset="-120"/>
-              </a:rPr>
-              <a:t>Duy trì dữ liệu cập nhật</a:t>
-            </a:r>
-            <a:endParaRPr lang="en-US" sz="1050" dirty="0"/>
-          </a:p>
-          <a:p>
-            <a:pPr algn="ctr" indent="0" marL="0">
-              <a:lnSpc>
-                <a:spcPct val="100000"/>
-              </a:lnSpc>
-              <a:buNone/>
-            </a:pPr>
-            <a:r>
-              <a:rPr lang="en-US" sz="1050" dirty="0">
-                <a:solidFill>
-                  <a:srgbClr val="253B5F"/>
-                </a:solidFill>
-                <a:latin typeface="Aptos" pitchFamily="34" charset="0"/>
-                <a:ea typeface="Aptos" pitchFamily="34" charset="-122"/>
-                <a:cs typeface="Aptos" pitchFamily="34" charset="-120"/>
-              </a:rPr>
-              <a:t>Trách nhiệm khi cảnh báo sai</a:t>
-            </a:r>
-            <a:endParaRPr lang="en-US" sz="1050" dirty="0"/>
-          </a:p>
-        </p:txBody>
-      </p:sp>
-      <p:sp>
-        <p:nvSpPr>
-          <p:cNvPr id="17" name="Text 15"/>
-          <p:cNvSpPr txBox="1"/>
-          <p:nvPr/>
-        </p:nvSpPr>
-        <p:spPr>
-          <a:xfrm>
-            <a:off x="530352" y="3794760"/>
-            <a:ext cx="2194560" cy="256032"/>
+          <p:cNvPr id="19" name="Text 17"/>
+          <p:cNvSpPr txBox="1"/>
+          <p:nvPr/>
+        </p:nvSpPr>
+        <p:spPr>
+          <a:xfrm>
+            <a:off x="6295644" y="2121408"/>
+            <a:ext cx="1473708" cy="457200"/>
           </a:xfrm>
           <a:prstGeom prst="rect">
             <a:avLst/>
@@ -5182,7 +5199,325 @@
               <a:buNone/>
             </a:pPr>
             <a:r>
-              <a:rPr lang="en-US" sz="1000" b="1" spc="120" kern="0" dirty="0">
+              <a:rPr lang="en-US" sz="1900" b="1" dirty="0">
+                <a:solidFill>
+                  <a:srgbClr val="2C9A83"/>
+                </a:solidFill>
+                <a:latin typeface="Aptos" pitchFamily="34" charset="0"/>
+                <a:ea typeface="Aptos" pitchFamily="34" charset="-122"/>
+                <a:cs typeface="Aptos" pitchFamily="34" charset="-120"/>
+              </a:rPr>
+              <a:t>100%</a:t>
+            </a:r>
+            <a:endParaRPr lang="en-US" sz="1900" dirty="0"/>
+          </a:p>
+        </p:txBody>
+      </p:sp>
+      <p:sp>
+        <p:nvSpPr>
+          <p:cNvPr id="20" name="Text 18"/>
+          <p:cNvSpPr txBox="1"/>
+          <p:nvPr/>
+        </p:nvSpPr>
+        <p:spPr>
+          <a:xfrm>
+            <a:off x="6295644" y="2596896"/>
+            <a:ext cx="1473708" cy="292608"/>
+          </a:xfrm>
+          <a:prstGeom prst="rect">
+            <a:avLst/>
+          </a:prstGeom>
+          <a:noFill/>
+          <a:ln/>
+        </p:spPr>
+        <p:txBody>
+          <a:bodyPr wrap="square" lIns="0" tIns="0" rIns="0" bIns="0" rtlCol="0" anchor="ctr">
+            <a:normAutofit/>
+          </a:bodyPr>
+          <a:lstStyle/>
+          <a:p>
+            <a:pPr algn="l" indent="0" marL="0">
+              <a:lnSpc>
+                <a:spcPct val="100000"/>
+              </a:lnSpc>
+              <a:buNone/>
+            </a:pPr>
+            <a:r>
+              <a:rPr lang="en-US" sz="1000" b="1" dirty="0">
+                <a:solidFill>
+                  <a:srgbClr val="11284C"/>
+                </a:solidFill>
+                <a:latin typeface="Aptos" pitchFamily="34" charset="0"/>
+                <a:ea typeface="Aptos" pitchFamily="34" charset="-122"/>
+                <a:cs typeface="Aptos" pitchFamily="34" charset="-120"/>
+              </a:rPr>
+              <a:t>Guardrail</a:t>
+            </a:r>
+            <a:endParaRPr lang="en-US" sz="1000" dirty="0"/>
+          </a:p>
+        </p:txBody>
+      </p:sp>
+      <p:sp>
+        <p:nvSpPr>
+          <p:cNvPr id="21" name="Text 19"/>
+          <p:cNvSpPr txBox="1"/>
+          <p:nvPr/>
+        </p:nvSpPr>
+        <p:spPr>
+          <a:xfrm>
+            <a:off x="6295644" y="2880360"/>
+            <a:ext cx="1473708" cy="219456"/>
+          </a:xfrm>
+          <a:prstGeom prst="rect">
+            <a:avLst/>
+          </a:prstGeom>
+          <a:noFill/>
+          <a:ln/>
+        </p:spPr>
+        <p:txBody>
+          <a:bodyPr wrap="square" lIns="0" tIns="0" rIns="0" bIns="0" rtlCol="0" anchor="ctr">
+            <a:normAutofit/>
+          </a:bodyPr>
+          <a:lstStyle/>
+          <a:p>
+            <a:pPr algn="l" indent="0" marL="0">
+              <a:lnSpc>
+                <a:spcPct val="100000"/>
+              </a:lnSpc>
+              <a:buNone/>
+            </a:pPr>
+            <a:r>
+              <a:rPr lang="en-US" sz="840" dirty="0">
+                <a:solidFill>
+                  <a:srgbClr val="667792"/>
+                </a:solidFill>
+                <a:latin typeface="Aptos" pitchFamily="34" charset="0"/>
+                <a:ea typeface="Aptos" pitchFamily="34" charset="-122"/>
+                <a:cs typeface="Aptos" pitchFamily="34" charset="-120"/>
+              </a:rPr>
+              <a:t>sau khi vá</a:t>
+            </a:r>
+            <a:endParaRPr lang="en-US" sz="840" dirty="0"/>
+          </a:p>
+        </p:txBody>
+      </p:sp>
+      <p:sp>
+        <p:nvSpPr>
+          <p:cNvPr id="22" name="Shape 20"/>
+          <p:cNvSpPr/>
+          <p:nvPr/>
+        </p:nvSpPr>
+        <p:spPr>
+          <a:xfrm>
+            <a:off x="8034528" y="1993392"/>
+            <a:ext cx="1748028" cy="1170432"/>
+          </a:xfrm>
+          <a:prstGeom prst="roundRect">
+            <a:avLst>
+              <a:gd name="adj" fmla="val 12500"/>
+            </a:avLst>
+          </a:prstGeom>
+          <a:solidFill>
+            <a:srgbClr val="FFF1D9"/>
+          </a:solidFill>
+          <a:ln w="12700">
+            <a:solidFill>
+              <a:srgbClr val="FFF1D9"/>
+            </a:solidFill>
+            <a:prstDash val="solid"/>
+          </a:ln>
+        </p:spPr>
+      </p:sp>
+      <p:sp>
+        <p:nvSpPr>
+          <p:cNvPr id="23" name="Text 21"/>
+          <p:cNvSpPr txBox="1"/>
+          <p:nvPr/>
+        </p:nvSpPr>
+        <p:spPr>
+          <a:xfrm>
+            <a:off x="8171688" y="2121408"/>
+            <a:ext cx="1473708" cy="457200"/>
+          </a:xfrm>
+          <a:prstGeom prst="rect">
+            <a:avLst/>
+          </a:prstGeom>
+          <a:noFill/>
+          <a:ln/>
+        </p:spPr>
+        <p:txBody>
+          <a:bodyPr wrap="square" lIns="0" tIns="0" rIns="0" bIns="0" rtlCol="0" anchor="ctr">
+            <a:normAutofit/>
+          </a:bodyPr>
+          <a:lstStyle/>
+          <a:p>
+            <a:pPr algn="l" indent="0" marL="0">
+              <a:lnSpc>
+                <a:spcPct val="100000"/>
+              </a:lnSpc>
+              <a:buNone/>
+            </a:pPr>
+            <a:r>
+              <a:rPr lang="en-US" sz="1900" b="1" dirty="0">
+                <a:solidFill>
+                  <a:srgbClr val="C68A2E"/>
+                </a:solidFill>
+                <a:latin typeface="Aptos" pitchFamily="34" charset="0"/>
+                <a:ea typeface="Aptos" pitchFamily="34" charset="-122"/>
+                <a:cs typeface="Aptos" pitchFamily="34" charset="-120"/>
+              </a:rPr>
+              <a:t>89%</a:t>
+            </a:r>
+            <a:endParaRPr lang="en-US" sz="1900" dirty="0"/>
+          </a:p>
+        </p:txBody>
+      </p:sp>
+      <p:sp>
+        <p:nvSpPr>
+          <p:cNvPr id="24" name="Text 22"/>
+          <p:cNvSpPr txBox="1"/>
+          <p:nvPr/>
+        </p:nvSpPr>
+        <p:spPr>
+          <a:xfrm>
+            <a:off x="8171688" y="2596896"/>
+            <a:ext cx="1473708" cy="292608"/>
+          </a:xfrm>
+          <a:prstGeom prst="rect">
+            <a:avLst/>
+          </a:prstGeom>
+          <a:noFill/>
+          <a:ln/>
+        </p:spPr>
+        <p:txBody>
+          <a:bodyPr wrap="square" lIns="0" tIns="0" rIns="0" bIns="0" rtlCol="0" anchor="ctr">
+            <a:normAutofit/>
+          </a:bodyPr>
+          <a:lstStyle/>
+          <a:p>
+            <a:pPr algn="l" indent="0" marL="0">
+              <a:lnSpc>
+                <a:spcPct val="100000"/>
+              </a:lnSpc>
+              <a:buNone/>
+            </a:pPr>
+            <a:r>
+              <a:rPr lang="en-US" sz="1000" b="1" dirty="0">
+                <a:solidFill>
+                  <a:srgbClr val="11284C"/>
+                </a:solidFill>
+                <a:latin typeface="Aptos" pitchFamily="34" charset="0"/>
+                <a:ea typeface="Aptos" pitchFamily="34" charset="-122"/>
+                <a:cs typeface="Aptos" pitchFamily="34" charset="-120"/>
+              </a:rPr>
+              <a:t>Consistency</a:t>
+            </a:r>
+            <a:endParaRPr lang="en-US" sz="1000" dirty="0"/>
+          </a:p>
+        </p:txBody>
+      </p:sp>
+      <p:sp>
+        <p:nvSpPr>
+          <p:cNvPr id="25" name="Text 23"/>
+          <p:cNvSpPr txBox="1"/>
+          <p:nvPr/>
+        </p:nvSpPr>
+        <p:spPr>
+          <a:xfrm>
+            <a:off x="8171688" y="2880360"/>
+            <a:ext cx="1473708" cy="219456"/>
+          </a:xfrm>
+          <a:prstGeom prst="rect">
+            <a:avLst/>
+          </a:prstGeom>
+          <a:noFill/>
+          <a:ln/>
+        </p:spPr>
+        <p:txBody>
+          <a:bodyPr wrap="square" lIns="0" tIns="0" rIns="0" bIns="0" rtlCol="0" anchor="ctr">
+            <a:normAutofit/>
+          </a:bodyPr>
+          <a:lstStyle/>
+          <a:p>
+            <a:pPr algn="l" indent="0" marL="0">
+              <a:lnSpc>
+                <a:spcPct val="100000"/>
+              </a:lnSpc>
+              <a:buNone/>
+            </a:pPr>
+            <a:r>
+              <a:rPr lang="en-US" sz="840" dirty="0">
+                <a:solidFill>
+                  <a:srgbClr val="667792"/>
+                </a:solidFill>
+                <a:latin typeface="Aptos" pitchFamily="34" charset="0"/>
+                <a:ea typeface="Aptos" pitchFamily="34" charset="-122"/>
+                <a:cs typeface="Aptos" pitchFamily="34" charset="-120"/>
+              </a:rPr>
+              <a:t>mục tiêu 100%</a:t>
+            </a:r>
+            <a:endParaRPr lang="en-US" sz="840" dirty="0"/>
+          </a:p>
+        </p:txBody>
+      </p:sp>
+      <p:sp>
+        <p:nvSpPr>
+          <p:cNvPr id="26" name="Shape 24"/>
+          <p:cNvSpPr/>
+          <p:nvPr/>
+        </p:nvSpPr>
+        <p:spPr>
+          <a:xfrm>
+            <a:off x="9910572" y="1993392"/>
+            <a:ext cx="1748028" cy="1170432"/>
+          </a:xfrm>
+          <a:prstGeom prst="roundRect">
+            <a:avLst>
+              <a:gd name="adj" fmla="val 12500"/>
+            </a:avLst>
+          </a:prstGeom>
+          <a:solidFill>
+            <a:srgbClr val="E9F0FF"/>
+          </a:solidFill>
+          <a:ln w="12700">
+            <a:solidFill>
+              <a:srgbClr val="E9F0FF"/>
+            </a:solidFill>
+            <a:prstDash val="solid"/>
+          </a:ln>
+        </p:spPr>
+      </p:sp>
+      <p:sp>
+        <p:nvSpPr>
+          <p:cNvPr id="27" name="Text 25"/>
+          <p:cNvSpPr txBox="1"/>
+          <p:nvPr/>
+        </p:nvSpPr>
+        <p:spPr>
+          <a:xfrm>
+            <a:off x="10047732" y="2121408"/>
+            <a:ext cx="1473708" cy="457200"/>
+          </a:xfrm>
+          <a:prstGeom prst="rect">
+            <a:avLst/>
+          </a:prstGeom>
+          <a:noFill/>
+          <a:ln/>
+        </p:spPr>
+        <p:txBody>
+          <a:bodyPr wrap="square" lIns="0" tIns="0" rIns="0" bIns="0" rtlCol="0" anchor="ctr">
+            <a:normAutofit/>
+          </a:bodyPr>
+          <a:lstStyle/>
+          <a:p>
+            <a:pPr algn="l" indent="0" marL="0">
+              <a:lnSpc>
+                <a:spcPct val="100000"/>
+              </a:lnSpc>
+              <a:buNone/>
+            </a:pPr>
+            <a:r>
+              <a:rPr lang="en-US" sz="1900" b="1" dirty="0">
                 <a:solidFill>
                   <a:srgbClr val="4D73C9"/>
                 </a:solidFill>
@@ -5190,7 +5525,51 @@
                 <a:ea typeface="Aptos" pitchFamily="34" charset="-122"/>
                 <a:cs typeface="Aptos" pitchFamily="34" charset="-120"/>
               </a:rPr>
-              <a:t>ROADMAP ĐỀ XUẤT</a:t>
+              <a:t>$0.0004</a:t>
+            </a:r>
+            <a:endParaRPr lang="en-US" sz="1900" dirty="0"/>
+          </a:p>
+        </p:txBody>
+      </p:sp>
+      <p:sp>
+        <p:nvSpPr>
+          <p:cNvPr id="28" name="Text 26"/>
+          <p:cNvSpPr txBox="1"/>
+          <p:nvPr/>
+        </p:nvSpPr>
+        <p:spPr>
+          <a:xfrm>
+            <a:off x="10047732" y="2596896"/>
+            <a:ext cx="1473708" cy="292608"/>
+          </a:xfrm>
+          <a:prstGeom prst="rect">
+            <a:avLst/>
+          </a:prstGeom>
+          <a:noFill/>
+          <a:ln/>
+        </p:spPr>
+        <p:txBody>
+          <a:bodyPr wrap="square" lIns="0" tIns="0" rIns="0" bIns="0" rtlCol="0" anchor="ctr">
+            <a:normAutofit/>
+          </a:bodyPr>
+          <a:lstStyle/>
+          <a:p>
+            <a:pPr algn="l" indent="0" marL="0">
+              <a:lnSpc>
+                <a:spcPct val="100000"/>
+              </a:lnSpc>
+              <a:buNone/>
+            </a:pPr>
+            <a:r>
+              <a:rPr lang="en-US" sz="1000" b="1" dirty="0">
+                <a:solidFill>
+                  <a:srgbClr val="11284C"/>
+                </a:solidFill>
+                <a:latin typeface="Aptos" pitchFamily="34" charset="0"/>
+                <a:ea typeface="Aptos" pitchFamily="34" charset="-122"/>
+                <a:cs typeface="Aptos" pitchFamily="34" charset="-120"/>
+              </a:rPr>
+              <a:t>Chi phí / lượt</a:t>
             </a:r>
             <a:endParaRPr lang="en-US" sz="1000" dirty="0"/>
           </a:p>
@@ -5198,16 +5577,131 @@
       </p:sp>
       <p:sp>
         <p:nvSpPr>
-          <p:cNvPr id="18" name="Shape 16"/>
+          <p:cNvPr id="29" name="Text 27"/>
+          <p:cNvSpPr txBox="1"/>
+          <p:nvPr/>
+        </p:nvSpPr>
+        <p:spPr>
+          <a:xfrm>
+            <a:off x="10047732" y="2880360"/>
+            <a:ext cx="1473708" cy="219456"/>
+          </a:xfrm>
+          <a:prstGeom prst="rect">
+            <a:avLst/>
+          </a:prstGeom>
+          <a:noFill/>
+          <a:ln/>
+        </p:spPr>
+        <p:txBody>
+          <a:bodyPr wrap="square" lIns="0" tIns="0" rIns="0" bIns="0" rtlCol="0" anchor="ctr">
+            <a:normAutofit/>
+          </a:bodyPr>
+          <a:lstStyle/>
+          <a:p>
+            <a:pPr algn="l" indent="0" marL="0">
+              <a:lnSpc>
+                <a:spcPct val="100000"/>
+              </a:lnSpc>
+              <a:buNone/>
+            </a:pPr>
+            <a:r>
+              <a:rPr lang="en-US" sz="840" dirty="0">
+                <a:solidFill>
+                  <a:srgbClr val="667792"/>
+                </a:solidFill>
+                <a:latin typeface="Aptos" pitchFamily="34" charset="0"/>
+                <a:ea typeface="Aptos" pitchFamily="34" charset="-122"/>
+                <a:cs typeface="Aptos" pitchFamily="34" charset="-120"/>
+              </a:rPr>
+              <a:t>cache ấm</a:t>
+            </a:r>
+            <a:endParaRPr lang="en-US" sz="840" dirty="0"/>
+          </a:p>
+        </p:txBody>
+      </p:sp>
+      <p:sp>
+        <p:nvSpPr>
+          <p:cNvPr id="30" name="Text 28"/>
+          <p:cNvSpPr txBox="1"/>
+          <p:nvPr/>
+        </p:nvSpPr>
+        <p:spPr>
+          <a:xfrm>
+            <a:off x="530352" y="3401568"/>
+            <a:ext cx="2743200" cy="237744"/>
+          </a:xfrm>
+          <a:prstGeom prst="rect">
+            <a:avLst/>
+          </a:prstGeom>
+          <a:noFill/>
+          <a:ln/>
+        </p:spPr>
+        <p:txBody>
+          <a:bodyPr wrap="square" lIns="0" tIns="0" rIns="0" bIns="0" rtlCol="0" anchor="ctr">
+            <a:normAutofit/>
+          </a:bodyPr>
+          <a:lstStyle/>
+          <a:p>
+            <a:pPr algn="l" indent="0" marL="0">
+              <a:lnSpc>
+                <a:spcPct val="100000"/>
+              </a:lnSpc>
+              <a:buNone/>
+            </a:pPr>
+            <a:r>
+              <a:rPr lang="en-US" sz="1000" b="1" spc="130" kern="0" dirty="0">
+                <a:solidFill>
+                  <a:srgbClr val="4D73C9"/>
+                </a:solidFill>
+                <a:latin typeface="Aptos" pitchFamily="34" charset="0"/>
+                <a:ea typeface="Aptos" pitchFamily="34" charset="-122"/>
+                <a:cs typeface="Aptos" pitchFamily="34" charset="-120"/>
+              </a:rPr>
+              <a:t>ĐIỂM NỔI BẬT</a:t>
+            </a:r>
+            <a:endParaRPr lang="en-US" sz="1000" dirty="0"/>
+          </a:p>
+        </p:txBody>
+      </p:sp>
+      <p:sp>
+        <p:nvSpPr>
+          <p:cNvPr id="31" name="Shape 29"/>
           <p:cNvSpPr/>
           <p:nvPr/>
         </p:nvSpPr>
         <p:spPr>
           <a:xfrm>
-            <a:off x="530352" y="4315968"/>
-            <a:ext cx="429768" cy="429768"/>
-          </a:xfrm>
-          <a:prstGeom prst="ellipse">
+            <a:off x="530352" y="3712464"/>
+            <a:ext cx="3587496" cy="1828800"/>
+          </a:xfrm>
+          <a:prstGeom prst="roundRect">
+            <a:avLst>
+              <a:gd name="adj" fmla="val 9000"/>
+            </a:avLst>
+          </a:prstGeom>
+          <a:solidFill>
+            <a:srgbClr val="FFFFFF"/>
+          </a:solidFill>
+          <a:ln w="12700">
+            <a:solidFill>
+              <a:srgbClr val="CBD8ED"/>
+            </a:solidFill>
+            <a:prstDash val="solid"/>
+          </a:ln>
+        </p:spPr>
+      </p:sp>
+      <p:sp>
+        <p:nvSpPr>
+          <p:cNvPr id="32" name="Shape 30"/>
+          <p:cNvSpPr/>
+          <p:nvPr/>
+        </p:nvSpPr>
+        <p:spPr>
+          <a:xfrm>
+            <a:off x="530352" y="3712464"/>
+            <a:ext cx="73152" cy="1828800"/>
+          </a:xfrm>
+          <a:prstGeom prst="rect">
             <a:avLst/>
           </a:prstGeom>
           <a:solidFill>
@@ -5223,171 +5717,14 @@
       </p:sp>
       <p:sp>
         <p:nvSpPr>
-          <p:cNvPr id="19" name="Text 17"/>
-          <p:cNvSpPr txBox="1"/>
-          <p:nvPr/>
-        </p:nvSpPr>
-        <p:spPr>
-          <a:xfrm>
-            <a:off x="530352" y="4343400"/>
-            <a:ext cx="429768" cy="310896"/>
-          </a:xfrm>
-          <a:prstGeom prst="rect">
-            <a:avLst/>
-          </a:prstGeom>
-          <a:noFill/>
-          <a:ln/>
-        </p:spPr>
-        <p:txBody>
-          <a:bodyPr wrap="square" lIns="0" tIns="0" rIns="0" bIns="0" rtlCol="0" anchor="ctr">
-            <a:normAutofit/>
-          </a:bodyPr>
-          <a:lstStyle/>
-          <a:p>
-            <a:pPr algn="ctr" indent="0" marL="0">
-              <a:lnSpc>
-                <a:spcPct val="100000"/>
-              </a:lnSpc>
-              <a:buNone/>
-            </a:pPr>
-            <a:r>
-              <a:rPr lang="en-US" sz="920" b="1" dirty="0">
-                <a:solidFill>
-                  <a:srgbClr val="FFFFFF"/>
-                </a:solidFill>
-                <a:latin typeface="Aptos" pitchFamily="34" charset="0"/>
-                <a:ea typeface="Aptos" pitchFamily="34" charset="-122"/>
-                <a:cs typeface="Aptos" pitchFamily="34" charset="-120"/>
-              </a:rPr>
-              <a:t>01</a:t>
-            </a:r>
-            <a:endParaRPr lang="en-US" sz="920" dirty="0"/>
-          </a:p>
-        </p:txBody>
-      </p:sp>
-      <p:sp>
-        <p:nvSpPr>
-          <p:cNvPr id="20" name="Shape 18"/>
+          <p:cNvPr id="33" name="Shape 31"/>
           <p:cNvSpPr/>
           <p:nvPr/>
         </p:nvSpPr>
         <p:spPr>
           <a:xfrm>
-            <a:off x="1005840" y="4535424"/>
-            <a:ext cx="2103120" cy="0"/>
-          </a:xfrm>
-          <a:prstGeom prst="line">
-            <a:avLst/>
-          </a:prstGeom>
-          <a:noFill/>
-          <a:ln w="17780">
-            <a:solidFill>
-              <a:srgbClr val="CBD8ED"/>
-            </a:solidFill>
-            <a:prstDash val="solid"/>
-            <a:headEnd type="none"/>
-            <a:tailEnd type="triangle"/>
-          </a:ln>
-        </p:spPr>
-      </p:sp>
-      <p:sp>
-        <p:nvSpPr>
-          <p:cNvPr id="21" name="Text 19"/>
-          <p:cNvSpPr txBox="1"/>
-          <p:nvPr/>
-        </p:nvSpPr>
-        <p:spPr>
-          <a:xfrm>
-            <a:off x="530352" y="4919472"/>
-            <a:ext cx="2487168" cy="256032"/>
-          </a:xfrm>
-          <a:prstGeom prst="rect">
-            <a:avLst/>
-          </a:prstGeom>
-          <a:noFill/>
-          <a:ln/>
-        </p:spPr>
-        <p:txBody>
-          <a:bodyPr wrap="square" lIns="0" tIns="0" rIns="0" bIns="0" rtlCol="0" anchor="ctr">
-            <a:normAutofit/>
-          </a:bodyPr>
-          <a:lstStyle/>
-          <a:p>
-            <a:pPr algn="l" indent="0" marL="0">
-              <a:lnSpc>
-                <a:spcPct val="100000"/>
-              </a:lnSpc>
-              <a:buNone/>
-            </a:pPr>
-            <a:r>
-              <a:rPr lang="en-US" sz="1050" b="1" dirty="0">
-                <a:solidFill>
-                  <a:srgbClr val="11284C"/>
-                </a:solidFill>
-                <a:latin typeface="Aptos" pitchFamily="34" charset="0"/>
-                <a:ea typeface="Aptos" pitchFamily="34" charset="-122"/>
-                <a:cs typeface="Aptos" pitchFamily="34" charset="-120"/>
-              </a:rPr>
-              <a:t>ĐO LƯỜNG</a:t>
-            </a:r>
-            <a:endParaRPr lang="en-US" sz="1050" dirty="0"/>
-          </a:p>
-        </p:txBody>
-      </p:sp>
-      <p:sp>
-        <p:nvSpPr>
-          <p:cNvPr id="22" name="Text 20"/>
-          <p:cNvSpPr txBox="1"/>
-          <p:nvPr/>
-        </p:nvSpPr>
-        <p:spPr>
-          <a:xfrm>
-            <a:off x="530352" y="5294376"/>
-            <a:ext cx="2487168" cy="658368"/>
-          </a:xfrm>
-          <a:prstGeom prst="rect">
-            <a:avLst/>
-          </a:prstGeom>
-          <a:noFill/>
-          <a:ln/>
-        </p:spPr>
-        <p:txBody>
-          <a:bodyPr wrap="square" lIns="0" tIns="0" rIns="0" bIns="0" rtlCol="0" anchor="t">
-            <a:normAutofit/>
-          </a:bodyPr>
-          <a:lstStyle/>
-          <a:p>
-            <a:pPr algn="l" indent="0" marL="0">
-              <a:lnSpc>
-                <a:spcPct val="100000"/>
-              </a:lnSpc>
-              <a:buNone/>
-            </a:pPr>
-            <a:r>
-              <a:rPr lang="en-US" sz="1020" dirty="0">
-                <a:solidFill>
-                  <a:srgbClr val="667792"/>
-                </a:solidFill>
-                <a:latin typeface="Aptos" pitchFamily="34" charset="0"/>
-                <a:ea typeface="Aptos" pitchFamily="34" charset="-122"/>
-                <a:cs typeface="Aptos" pitchFamily="34" charset="-120"/>
-              </a:rPr>
-              <a:t>Bộ test chuẩn; accuracy, latency, citation coverage</a:t>
-            </a:r>
-            <a:endParaRPr lang="en-US" sz="1020" dirty="0"/>
-          </a:p>
-        </p:txBody>
-      </p:sp>
-      <p:sp>
-        <p:nvSpPr>
-          <p:cNvPr id="23" name="Shape 21"/>
-          <p:cNvSpPr/>
-          <p:nvPr/>
-        </p:nvSpPr>
-        <p:spPr>
-          <a:xfrm>
-            <a:off x="3319272" y="4315968"/>
-            <a:ext cx="429768" cy="429768"/>
+            <a:off x="758952" y="3959352"/>
+            <a:ext cx="384048" cy="384048"/>
           </a:xfrm>
           <a:prstGeom prst="ellipse">
             <a:avLst/>
@@ -5405,14 +5742,14 @@
       </p:sp>
       <p:sp>
         <p:nvSpPr>
-          <p:cNvPr id="24" name="Text 22"/>
-          <p:cNvSpPr txBox="1"/>
-          <p:nvPr/>
-        </p:nvSpPr>
-        <p:spPr>
-          <a:xfrm>
-            <a:off x="3319272" y="4343400"/>
-            <a:ext cx="429768" cy="310896"/>
+          <p:cNvPr id="34" name="Text 32"/>
+          <p:cNvSpPr txBox="1"/>
+          <p:nvPr/>
+        </p:nvSpPr>
+        <p:spPr>
+          <a:xfrm>
+            <a:off x="758952" y="3968496"/>
+            <a:ext cx="384048" cy="347472"/>
           </a:xfrm>
           <a:prstGeom prst="rect">
             <a:avLst/>
@@ -5433,7 +5770,7 @@
               <a:buNone/>
             </a:pPr>
             <a:r>
-              <a:rPr lang="en-US" sz="920" b="1" dirty="0">
+              <a:rPr lang="en-US" sz="1000" b="1" dirty="0">
                 <a:solidFill>
                   <a:srgbClr val="FFFFFF"/>
                 </a:solidFill>
@@ -5441,145 +5778,147 @@
                 <a:ea typeface="Aptos" pitchFamily="34" charset="-122"/>
                 <a:cs typeface="Aptos" pitchFamily="34" charset="-120"/>
               </a:rPr>
-              <a:t>02</a:t>
-            </a:r>
-            <a:endParaRPr lang="en-US" sz="920" dirty="0"/>
-          </a:p>
-        </p:txBody>
-      </p:sp>
-      <p:sp>
-        <p:nvSpPr>
-          <p:cNvPr id="25" name="Shape 23"/>
+              <a:t>01</a:t>
+            </a:r>
+            <a:endParaRPr lang="en-US" sz="1000" dirty="0"/>
+          </a:p>
+        </p:txBody>
+      </p:sp>
+      <p:sp>
+        <p:nvSpPr>
+          <p:cNvPr id="35" name="Text 33"/>
+          <p:cNvSpPr txBox="1"/>
+          <p:nvPr/>
+        </p:nvSpPr>
+        <p:spPr>
+          <a:xfrm>
+            <a:off x="1280160" y="3922776"/>
+            <a:ext cx="2654808" cy="347472"/>
+          </a:xfrm>
+          <a:prstGeom prst="rect">
+            <a:avLst/>
+          </a:prstGeom>
+          <a:noFill/>
+          <a:ln/>
+        </p:spPr>
+        <p:txBody>
+          <a:bodyPr wrap="square" lIns="0" tIns="0" rIns="0" bIns="0" rtlCol="0" anchor="ctr">
+            <a:normAutofit/>
+          </a:bodyPr>
+          <a:lstStyle/>
+          <a:p>
+            <a:pPr algn="l" indent="0" marL="0">
+              <a:lnSpc>
+                <a:spcPct val="100000"/>
+              </a:lnSpc>
+              <a:buNone/>
+            </a:pPr>
+            <a:r>
+              <a:rPr lang="en-US" sz="1500" b="1" dirty="0">
+                <a:solidFill>
+                  <a:srgbClr val="11284C"/>
+                </a:solidFill>
+                <a:latin typeface="Aptos" pitchFamily="34" charset="0"/>
+                <a:ea typeface="Aptos" pitchFamily="34" charset="-122"/>
+                <a:cs typeface="Aptos" pitchFamily="34" charset="-120"/>
+              </a:rPr>
+              <a:t>Đổi giám khảo, không tự chấm mình</a:t>
+            </a:r>
+            <a:endParaRPr lang="en-US" sz="1500" dirty="0"/>
+          </a:p>
+        </p:txBody>
+      </p:sp>
+      <p:sp>
+        <p:nvSpPr>
+          <p:cNvPr id="36" name="Text 34"/>
+          <p:cNvSpPr txBox="1"/>
+          <p:nvPr/>
+        </p:nvSpPr>
+        <p:spPr>
+          <a:xfrm>
+            <a:off x="786384" y="4379976"/>
+            <a:ext cx="3075432" cy="996696"/>
+          </a:xfrm>
+          <a:prstGeom prst="rect">
+            <a:avLst/>
+          </a:prstGeom>
+          <a:noFill/>
+          <a:ln/>
+        </p:spPr>
+        <p:txBody>
+          <a:bodyPr wrap="square" lIns="0" tIns="0" rIns="0" bIns="0" rtlCol="0" anchor="t">
+            <a:normAutofit/>
+          </a:bodyPr>
+          <a:lstStyle/>
+          <a:p>
+            <a:pPr algn="l" indent="0" marL="0">
+              <a:lnSpc>
+                <a:spcPct val="105000"/>
+              </a:lnSpc>
+              <a:buNone/>
+            </a:pPr>
+            <a:r>
+              <a:rPr lang="en-US" sz="1120" dirty="0">
+                <a:solidFill>
+                  <a:srgbClr val="667792"/>
+                </a:solidFill>
+                <a:latin typeface="Aptos" pitchFamily="34" charset="0"/>
+                <a:ea typeface="Aptos" pitchFamily="34" charset="-122"/>
+                <a:cs typeface="Aptos" pitchFamily="34" charset="-120"/>
+              </a:rPr>
+              <a:t>AI khác nhà cung cấp với model sinh nội dung được dùng để chấm — giảm thiên vị "tự chấm chính mình" so với đợt trước.</a:t>
+            </a:r>
+            <a:endParaRPr lang="en-US" sz="1120" dirty="0"/>
+          </a:p>
+        </p:txBody>
+      </p:sp>
+      <p:sp>
+        <p:nvSpPr>
+          <p:cNvPr id="37" name="Shape 35"/>
           <p:cNvSpPr/>
           <p:nvPr/>
         </p:nvSpPr>
         <p:spPr>
           <a:xfrm>
-            <a:off x="3794760" y="4535424"/>
-            <a:ext cx="2103120" cy="0"/>
-          </a:xfrm>
-          <a:prstGeom prst="line">
-            <a:avLst/>
-          </a:prstGeom>
-          <a:noFill/>
-          <a:ln w="17780">
+            <a:off x="4300728" y="3712464"/>
+            <a:ext cx="3587496" cy="1828800"/>
+          </a:xfrm>
+          <a:prstGeom prst="roundRect">
+            <a:avLst>
+              <a:gd name="adj" fmla="val 9000"/>
+            </a:avLst>
+          </a:prstGeom>
+          <a:solidFill>
+            <a:srgbClr val="FFFFFF"/>
+          </a:solidFill>
+          <a:ln w="12700">
             <a:solidFill>
               <a:srgbClr val="CBD8ED"/>
             </a:solidFill>
             <a:prstDash val="solid"/>
-            <a:headEnd type="none"/>
-            <a:tailEnd type="triangle"/>
           </a:ln>
         </p:spPr>
       </p:sp>
       <p:sp>
         <p:nvSpPr>
-          <p:cNvPr id="26" name="Text 24"/>
-          <p:cNvSpPr txBox="1"/>
-          <p:nvPr/>
-        </p:nvSpPr>
-        <p:spPr>
-          <a:xfrm>
-            <a:off x="3319272" y="4919472"/>
-            <a:ext cx="2487168" cy="256032"/>
-          </a:xfrm>
-          <a:prstGeom prst="rect">
-            <a:avLst/>
-          </a:prstGeom>
-          <a:noFill/>
-          <a:ln/>
-        </p:spPr>
-        <p:txBody>
-          <a:bodyPr wrap="square" lIns="0" tIns="0" rIns="0" bIns="0" rtlCol="0" anchor="ctr">
-            <a:normAutofit/>
-          </a:bodyPr>
-          <a:lstStyle/>
-          <a:p>
-            <a:pPr algn="l" indent="0" marL="0">
-              <a:lnSpc>
-                <a:spcPct val="100000"/>
-              </a:lnSpc>
-              <a:buNone/>
-            </a:pPr>
-            <a:r>
-              <a:rPr lang="en-US" sz="1050" b="1" dirty="0">
-                <a:solidFill>
-                  <a:srgbClr val="11284C"/>
-                </a:solidFill>
-                <a:latin typeface="Aptos" pitchFamily="34" charset="0"/>
-                <a:ea typeface="Aptos" pitchFamily="34" charset="-122"/>
-                <a:cs typeface="Aptos" pitchFamily="34" charset="-120"/>
-              </a:rPr>
-              <a:t>KIỂM CHỨNG</a:t>
-            </a:r>
-            <a:endParaRPr lang="en-US" sz="1050" dirty="0"/>
-          </a:p>
-        </p:txBody>
-      </p:sp>
-      <p:sp>
-        <p:nvSpPr>
-          <p:cNvPr id="27" name="Text 25"/>
-          <p:cNvSpPr txBox="1"/>
-          <p:nvPr/>
-        </p:nvSpPr>
-        <p:spPr>
-          <a:xfrm>
-            <a:off x="3319272" y="5294376"/>
-            <a:ext cx="2487168" cy="658368"/>
-          </a:xfrm>
-          <a:prstGeom prst="rect">
-            <a:avLst/>
-          </a:prstGeom>
-          <a:noFill/>
-          <a:ln/>
-        </p:spPr>
-        <p:txBody>
-          <a:bodyPr wrap="square" lIns="0" tIns="0" rIns="0" bIns="0" rtlCol="0" anchor="t">
-            <a:normAutofit/>
-          </a:bodyPr>
-          <a:lstStyle/>
-          <a:p>
-            <a:pPr algn="l" indent="0" marL="0">
-              <a:lnSpc>
-                <a:spcPct val="100000"/>
-              </a:lnSpc>
-              <a:buNone/>
-            </a:pPr>
-            <a:r>
-              <a:rPr lang="en-US" sz="1020" dirty="0">
-                <a:solidFill>
-                  <a:srgbClr val="667792"/>
-                </a:solidFill>
-                <a:latin typeface="Aptos" pitchFamily="34" charset="0"/>
-                <a:ea typeface="Aptos" pitchFamily="34" charset="-122"/>
-                <a:cs typeface="Aptos" pitchFamily="34" charset="-120"/>
-              </a:rPr>
-              <a:t>Pilot với dược sĩ; phân tích cảnh báo sai / bỏ sót</a:t>
-            </a:r>
-            <a:endParaRPr lang="en-US" sz="1020" dirty="0"/>
-          </a:p>
-        </p:txBody>
-      </p:sp>
-      <p:sp>
-        <p:nvSpPr>
-          <p:cNvPr id="28" name="Shape 26"/>
+          <p:cNvPr id="38" name="Shape 36"/>
           <p:cNvSpPr/>
           <p:nvPr/>
         </p:nvSpPr>
         <p:spPr>
           <a:xfrm>
-            <a:off x="6108192" y="4315968"/>
-            <a:ext cx="429768" cy="429768"/>
-          </a:xfrm>
-          <a:prstGeom prst="ellipse">
+            <a:off x="4300728" y="3712464"/>
+            <a:ext cx="73152" cy="1828800"/>
+          </a:xfrm>
+          <a:prstGeom prst="rect">
             <a:avLst/>
           </a:prstGeom>
           <a:solidFill>
-            <a:srgbClr val="4D73C9"/>
+            <a:srgbClr val="C68A2E"/>
           </a:solidFill>
           <a:ln w="12700">
             <a:solidFill>
-              <a:srgbClr val="4D73C9"/>
+              <a:srgbClr val="C68A2E"/>
             </a:solidFill>
             <a:prstDash val="solid"/>
           </a:ln>
@@ -5587,14 +5926,39 @@
       </p:sp>
       <p:sp>
         <p:nvSpPr>
-          <p:cNvPr id="29" name="Text 27"/>
-          <p:cNvSpPr txBox="1"/>
-          <p:nvPr/>
-        </p:nvSpPr>
-        <p:spPr>
-          <a:xfrm>
-            <a:off x="6108192" y="4343400"/>
-            <a:ext cx="429768" cy="310896"/>
+          <p:cNvPr id="39" name="Shape 37"/>
+          <p:cNvSpPr/>
+          <p:nvPr/>
+        </p:nvSpPr>
+        <p:spPr>
+          <a:xfrm>
+            <a:off x="4529328" y="3959352"/>
+            <a:ext cx="384048" cy="384048"/>
+          </a:xfrm>
+          <a:prstGeom prst="ellipse">
+            <a:avLst/>
+          </a:prstGeom>
+          <a:solidFill>
+            <a:srgbClr val="C68A2E"/>
+          </a:solidFill>
+          <a:ln w="12700">
+            <a:solidFill>
+              <a:srgbClr val="C68A2E"/>
+            </a:solidFill>
+            <a:prstDash val="solid"/>
+          </a:ln>
+        </p:spPr>
+      </p:sp>
+      <p:sp>
+        <p:nvSpPr>
+          <p:cNvPr id="40" name="Text 38"/>
+          <p:cNvSpPr txBox="1"/>
+          <p:nvPr/>
+        </p:nvSpPr>
+        <p:spPr>
+          <a:xfrm>
+            <a:off x="4529328" y="3968496"/>
+            <a:ext cx="384048" cy="347472"/>
           </a:xfrm>
           <a:prstGeom prst="rect">
             <a:avLst/>
@@ -5615,7 +5979,7 @@
               <a:buNone/>
             </a:pPr>
             <a:r>
-              <a:rPr lang="en-US" sz="920" b="1" dirty="0">
+              <a:rPr lang="en-US" sz="1000" b="1" dirty="0">
                 <a:solidFill>
                   <a:srgbClr val="FFFFFF"/>
                 </a:solidFill>
@@ -5623,137 +5987,139 @@
                 <a:ea typeface="Aptos" pitchFamily="34" charset="-122"/>
                 <a:cs typeface="Aptos" pitchFamily="34" charset="-120"/>
               </a:rPr>
-              <a:t>03</a:t>
-            </a:r>
-            <a:endParaRPr lang="en-US" sz="920" dirty="0"/>
-          </a:p>
-        </p:txBody>
-      </p:sp>
-      <p:sp>
-        <p:nvSpPr>
-          <p:cNvPr id="30" name="Shape 28"/>
+              <a:t>02</a:t>
+            </a:r>
+            <a:endParaRPr lang="en-US" sz="1000" dirty="0"/>
+          </a:p>
+        </p:txBody>
+      </p:sp>
+      <p:sp>
+        <p:nvSpPr>
+          <p:cNvPr id="41" name="Text 39"/>
+          <p:cNvSpPr txBox="1"/>
+          <p:nvPr/>
+        </p:nvSpPr>
+        <p:spPr>
+          <a:xfrm>
+            <a:off x="5050536" y="3922776"/>
+            <a:ext cx="2654808" cy="347472"/>
+          </a:xfrm>
+          <a:prstGeom prst="rect">
+            <a:avLst/>
+          </a:prstGeom>
+          <a:noFill/>
+          <a:ln/>
+        </p:spPr>
+        <p:txBody>
+          <a:bodyPr wrap="square" lIns="0" tIns="0" rIns="0" bIns="0" rtlCol="0" anchor="ctr">
+            <a:normAutofit/>
+          </a:bodyPr>
+          <a:lstStyle/>
+          <a:p>
+            <a:pPr algn="l" indent="0" marL="0">
+              <a:lnSpc>
+                <a:spcPct val="100000"/>
+              </a:lnSpc>
+              <a:buNone/>
+            </a:pPr>
+            <a:r>
+              <a:rPr lang="en-US" sz="1500" b="1" dirty="0">
+                <a:solidFill>
+                  <a:srgbClr val="11284C"/>
+                </a:solidFill>
+                <a:latin typeface="Aptos" pitchFamily="34" charset="0"/>
+                <a:ea typeface="Aptos" pitchFamily="34" charset="-122"/>
+                <a:cs typeface="Aptos" pitchFamily="34" charset="-120"/>
+              </a:rPr>
+              <a:t>Rà soát trước khi chấm diện rộng</a:t>
+            </a:r>
+            <a:endParaRPr lang="en-US" sz="1500" dirty="0"/>
+          </a:p>
+        </p:txBody>
+      </p:sp>
+      <p:sp>
+        <p:nvSpPr>
+          <p:cNvPr id="42" name="Text 40"/>
+          <p:cNvSpPr txBox="1"/>
+          <p:nvPr/>
+        </p:nvSpPr>
+        <p:spPr>
+          <a:xfrm>
+            <a:off x="4556760" y="4379976"/>
+            <a:ext cx="3075432" cy="996696"/>
+          </a:xfrm>
+          <a:prstGeom prst="rect">
+            <a:avLst/>
+          </a:prstGeom>
+          <a:noFill/>
+          <a:ln/>
+        </p:spPr>
+        <p:txBody>
+          <a:bodyPr wrap="square" lIns="0" tIns="0" rIns="0" bIns="0" rtlCol="0" anchor="t">
+            <a:normAutofit/>
+          </a:bodyPr>
+          <a:lstStyle/>
+          <a:p>
+            <a:pPr algn="l" indent="0" marL="0">
+              <a:lnSpc>
+                <a:spcPct val="105000"/>
+              </a:lnSpc>
+              <a:buNone/>
+            </a:pPr>
+            <a:r>
+              <a:rPr lang="en-US" sz="1120" dirty="0">
+                <a:solidFill>
+                  <a:srgbClr val="667792"/>
+                </a:solidFill>
+                <a:latin typeface="Aptos" pitchFamily="34" charset="0"/>
+                <a:ea typeface="Aptos" pitchFamily="34" charset="-122"/>
+                <a:cs typeface="Aptos" pitchFamily="34" charset="-120"/>
+              </a:rPr>
+              <a:t>Tìm và vá 5 kiểu rò rỉ lời khuyên xử trí ẩn trong văn bản, trước khi tốn chi phí đánh giá cả 135 case.</a:t>
+            </a:r>
+            <a:endParaRPr lang="en-US" sz="1120" dirty="0"/>
+          </a:p>
+        </p:txBody>
+      </p:sp>
+      <p:sp>
+        <p:nvSpPr>
+          <p:cNvPr id="43" name="Shape 41"/>
           <p:cNvSpPr/>
           <p:nvPr/>
         </p:nvSpPr>
         <p:spPr>
           <a:xfrm>
-            <a:off x="6583680" y="4535424"/>
-            <a:ext cx="2103120" cy="0"/>
-          </a:xfrm>
-          <a:prstGeom prst="line">
-            <a:avLst/>
-          </a:prstGeom>
-          <a:noFill/>
-          <a:ln w="17780">
+            <a:off x="8071104" y="3712464"/>
+            <a:ext cx="3587496" cy="1828800"/>
+          </a:xfrm>
+          <a:prstGeom prst="roundRect">
+            <a:avLst>
+              <a:gd name="adj" fmla="val 9000"/>
+            </a:avLst>
+          </a:prstGeom>
+          <a:solidFill>
+            <a:srgbClr val="FFFFFF"/>
+          </a:solidFill>
+          <a:ln w="12700">
             <a:solidFill>
               <a:srgbClr val="CBD8ED"/>
             </a:solidFill>
             <a:prstDash val="solid"/>
-            <a:headEnd type="none"/>
-            <a:tailEnd type="triangle"/>
           </a:ln>
         </p:spPr>
       </p:sp>
       <p:sp>
         <p:nvSpPr>
-          <p:cNvPr id="31" name="Text 29"/>
-          <p:cNvSpPr txBox="1"/>
-          <p:nvPr/>
-        </p:nvSpPr>
-        <p:spPr>
-          <a:xfrm>
-            <a:off x="6108192" y="4919472"/>
-            <a:ext cx="2487168" cy="256032"/>
-          </a:xfrm>
-          <a:prstGeom prst="rect">
-            <a:avLst/>
-          </a:prstGeom>
-          <a:noFill/>
-          <a:ln/>
-        </p:spPr>
-        <p:txBody>
-          <a:bodyPr wrap="square" lIns="0" tIns="0" rIns="0" bIns="0" rtlCol="0" anchor="ctr">
-            <a:normAutofit/>
-          </a:bodyPr>
-          <a:lstStyle/>
-          <a:p>
-            <a:pPr algn="l" indent="0" marL="0">
-              <a:lnSpc>
-                <a:spcPct val="100000"/>
-              </a:lnSpc>
-              <a:buNone/>
-            </a:pPr>
-            <a:r>
-              <a:rPr lang="en-US" sz="1050" b="1" dirty="0">
-                <a:solidFill>
-                  <a:srgbClr val="11284C"/>
-                </a:solidFill>
-                <a:latin typeface="Aptos" pitchFamily="34" charset="0"/>
-                <a:ea typeface="Aptos" pitchFamily="34" charset="-122"/>
-                <a:cs typeface="Aptos" pitchFamily="34" charset="-120"/>
-              </a:rPr>
-              <a:t>CỨNG HÓA</a:t>
-            </a:r>
-            <a:endParaRPr lang="en-US" sz="1050" dirty="0"/>
-          </a:p>
-        </p:txBody>
-      </p:sp>
-      <p:sp>
-        <p:nvSpPr>
-          <p:cNvPr id="32" name="Text 30"/>
-          <p:cNvSpPr txBox="1"/>
-          <p:nvPr/>
-        </p:nvSpPr>
-        <p:spPr>
-          <a:xfrm>
-            <a:off x="6108192" y="5294376"/>
-            <a:ext cx="2487168" cy="658368"/>
-          </a:xfrm>
-          <a:prstGeom prst="rect">
-            <a:avLst/>
-          </a:prstGeom>
-          <a:noFill/>
-          <a:ln/>
-        </p:spPr>
-        <p:txBody>
-          <a:bodyPr wrap="square" lIns="0" tIns="0" rIns="0" bIns="0" rtlCol="0" anchor="t">
-            <a:normAutofit/>
-          </a:bodyPr>
-          <a:lstStyle/>
-          <a:p>
-            <a:pPr algn="l" indent="0" marL="0">
-              <a:lnSpc>
-                <a:spcPct val="100000"/>
-              </a:lnSpc>
-              <a:buNone/>
-            </a:pPr>
-            <a:r>
-              <a:rPr lang="en-US" sz="1020" dirty="0">
-                <a:solidFill>
-                  <a:srgbClr val="667792"/>
-                </a:solidFill>
-                <a:latin typeface="Aptos" pitchFamily="34" charset="0"/>
-                <a:ea typeface="Aptos" pitchFamily="34" charset="-122"/>
-                <a:cs typeface="Aptos" pitchFamily="34" charset="-120"/>
-              </a:rPr>
-              <a:t>Monitoring, audit log, backup, privacy &amp; security review</a:t>
-            </a:r>
-            <a:endParaRPr lang="en-US" sz="1020" dirty="0"/>
-          </a:p>
-        </p:txBody>
-      </p:sp>
-      <p:sp>
-        <p:nvSpPr>
-          <p:cNvPr id="33" name="Shape 31"/>
+          <p:cNvPr id="44" name="Shape 42"/>
           <p:cNvSpPr/>
           <p:nvPr/>
         </p:nvSpPr>
         <p:spPr>
           <a:xfrm>
-            <a:off x="8897112" y="4315968"/>
-            <a:ext cx="429768" cy="429768"/>
-          </a:xfrm>
-          <a:prstGeom prst="ellipse">
+            <a:off x="8071104" y="3712464"/>
+            <a:ext cx="73152" cy="1828800"/>
+          </a:xfrm>
+          <a:prstGeom prst="rect">
             <a:avLst/>
           </a:prstGeom>
           <a:solidFill>
@@ -5769,14 +6135,39 @@
       </p:sp>
       <p:sp>
         <p:nvSpPr>
-          <p:cNvPr id="34" name="Text 32"/>
-          <p:cNvSpPr txBox="1"/>
-          <p:nvPr/>
-        </p:nvSpPr>
-        <p:spPr>
-          <a:xfrm>
-            <a:off x="8897112" y="4343400"/>
-            <a:ext cx="429768" cy="310896"/>
+          <p:cNvPr id="45" name="Shape 43"/>
+          <p:cNvSpPr/>
+          <p:nvPr/>
+        </p:nvSpPr>
+        <p:spPr>
+          <a:xfrm>
+            <a:off x="8299704" y="3959352"/>
+            <a:ext cx="384048" cy="384048"/>
+          </a:xfrm>
+          <a:prstGeom prst="ellipse">
+            <a:avLst/>
+          </a:prstGeom>
+          <a:solidFill>
+            <a:srgbClr val="2C9A83"/>
+          </a:solidFill>
+          <a:ln w="12700">
+            <a:solidFill>
+              <a:srgbClr val="2C9A83"/>
+            </a:solidFill>
+            <a:prstDash val="solid"/>
+          </a:ln>
+        </p:spPr>
+      </p:sp>
+      <p:sp>
+        <p:nvSpPr>
+          <p:cNvPr id="46" name="Text 44"/>
+          <p:cNvSpPr txBox="1"/>
+          <p:nvPr/>
+        </p:nvSpPr>
+        <p:spPr>
+          <a:xfrm>
+            <a:off x="8299704" y="3968496"/>
+            <a:ext cx="384048" cy="347472"/>
           </a:xfrm>
           <a:prstGeom prst="rect">
             <a:avLst/>
@@ -5797,7 +6188,7 @@
               <a:buNone/>
             </a:pPr>
             <a:r>
-              <a:rPr lang="en-US" sz="920" b="1" dirty="0">
+              <a:rPr lang="en-US" sz="1000" b="1" dirty="0">
                 <a:solidFill>
                   <a:srgbClr val="FFFFFF"/>
                 </a:solidFill>
@@ -5805,22 +6196,22 @@
                 <a:ea typeface="Aptos" pitchFamily="34" charset="-122"/>
                 <a:cs typeface="Aptos" pitchFamily="34" charset="-120"/>
               </a:rPr>
-              <a:t>04</a:t>
-            </a:r>
-            <a:endParaRPr lang="en-US" sz="920" dirty="0"/>
-          </a:p>
-        </p:txBody>
-      </p:sp>
-      <p:sp>
-        <p:nvSpPr>
-          <p:cNvPr id="35" name="Text 33"/>
-          <p:cNvSpPr txBox="1"/>
-          <p:nvPr/>
-        </p:nvSpPr>
-        <p:spPr>
-          <a:xfrm>
-            <a:off x="8897112" y="4919472"/>
-            <a:ext cx="2487168" cy="256032"/>
+              <a:t>03</a:t>
+            </a:r>
+            <a:endParaRPr lang="en-US" sz="1000" dirty="0"/>
+          </a:p>
+        </p:txBody>
+      </p:sp>
+      <p:sp>
+        <p:nvSpPr>
+          <p:cNvPr id="47" name="Text 45"/>
+          <p:cNvSpPr txBox="1"/>
+          <p:nvPr/>
+        </p:nvSpPr>
+        <p:spPr>
+          <a:xfrm>
+            <a:off x="8820912" y="3922776"/>
+            <a:ext cx="2654808" cy="347472"/>
           </a:xfrm>
           <a:prstGeom prst="rect">
             <a:avLst/>
@@ -5841,30 +6232,30 @@
               <a:buNone/>
             </a:pPr>
             <a:r>
-              <a:rPr lang="en-US" sz="1050" b="1" dirty="0">
-                <a:solidFill>
-                  <a:srgbClr val="2C9A83"/>
-                </a:solidFill>
-                <a:latin typeface="Aptos" pitchFamily="34" charset="0"/>
-                <a:ea typeface="Aptos" pitchFamily="34" charset="-122"/>
-                <a:cs typeface="Aptos" pitchFamily="34" charset="-120"/>
-              </a:rPr>
-              <a:t>MỞ RỘNG</a:t>
-            </a:r>
-            <a:endParaRPr lang="en-US" sz="1050" dirty="0"/>
-          </a:p>
-        </p:txBody>
-      </p:sp>
-      <p:sp>
-        <p:nvSpPr>
-          <p:cNvPr id="36" name="Text 34"/>
-          <p:cNvSpPr txBox="1"/>
-          <p:nvPr/>
-        </p:nvSpPr>
-        <p:spPr>
-          <a:xfrm>
-            <a:off x="8897112" y="5294376"/>
-            <a:ext cx="2487168" cy="658368"/>
+              <a:rPr lang="en-US" sz="1500" b="1" dirty="0">
+                <a:solidFill>
+                  <a:srgbClr val="11284C"/>
+                </a:solidFill>
+                <a:latin typeface="Aptos" pitchFamily="34" charset="0"/>
+                <a:ea typeface="Aptos" pitchFamily="34" charset="-122"/>
+                <a:cs typeface="Aptos" pitchFamily="34" charset="-120"/>
+              </a:rPr>
+              <a:t>Soát tay bắt lỗi ngoài khung có sẵn</a:t>
+            </a:r>
+            <a:endParaRPr lang="en-US" sz="1500" dirty="0"/>
+          </a:p>
+        </p:txBody>
+      </p:sp>
+      <p:sp>
+        <p:nvSpPr>
+          <p:cNvPr id="48" name="Text 46"/>
+          <p:cNvSpPr txBox="1"/>
+          <p:nvPr/>
+        </p:nvSpPr>
+        <p:spPr>
+          <a:xfrm>
+            <a:off x="8327136" y="4379976"/>
+            <a:ext cx="3075432" cy="996696"/>
           </a:xfrm>
           <a:prstGeom prst="rect">
             <a:avLst/>
@@ -5880,12 +6271,12 @@
           <a:p>
             <a:pPr algn="l" indent="0" marL="0">
               <a:lnSpc>
-                <a:spcPct val="100000"/>
-              </a:lnSpc>
-              <a:buNone/>
-            </a:pPr>
-            <a:r>
-              <a:rPr lang="en-US" sz="1020" dirty="0">
+                <a:spcPct val="105000"/>
+              </a:lnSpc>
+              <a:buNone/>
+            </a:pPr>
+            <a:r>
+              <a:rPr lang="en-US" sz="1120" dirty="0">
                 <a:solidFill>
                   <a:srgbClr val="667792"/>
                 </a:solidFill>
@@ -5893,9 +6284,80 @@
                 <a:ea typeface="Aptos" pitchFamily="34" charset="-122"/>
                 <a:cs typeface="Aptos" pitchFamily="34" charset="-120"/>
               </a:rPr>
-              <a:t>OCR tốt hơn, cá nhân hóa bệnh nền, mô hình B2B2C</a:t>
-            </a:r>
-            <a:endParaRPr lang="en-US" sz="1020" dirty="0"/>
+              <a:t>1 thành viên đọc trực tiếp, không cần chuyên môn y dược, phát hiện thêm 1 lỗi mà bộ tiêu chí tự động không bắt được.</a:t>
+            </a:r>
+            <a:endParaRPr lang="en-US" sz="1120" dirty="0"/>
+          </a:p>
+        </p:txBody>
+      </p:sp>
+      <p:sp>
+        <p:nvSpPr>
+          <p:cNvPr id="49" name="Shape 47"/>
+          <p:cNvSpPr/>
+          <p:nvPr/>
+        </p:nvSpPr>
+        <p:spPr>
+          <a:xfrm>
+            <a:off x="530352" y="5669280"/>
+            <a:ext cx="11128248" cy="438912"/>
+          </a:xfrm>
+          <a:prstGeom prst="roundRect">
+            <a:avLst>
+              <a:gd name="adj" fmla="val 29167"/>
+            </a:avLst>
+          </a:prstGeom>
+          <a:solidFill>
+            <a:srgbClr val="11284C"/>
+          </a:solidFill>
+          <a:ln w="12700">
+            <a:solidFill>
+              <a:srgbClr val="11284C"/>
+            </a:solidFill>
+            <a:prstDash val="solid"/>
+          </a:ln>
+        </p:spPr>
+      </p:sp>
+      <p:sp>
+        <p:nvSpPr>
+          <p:cNvPr id="50" name="Text 48"/>
+          <p:cNvSpPr txBox="1"/>
+          <p:nvPr/>
+        </p:nvSpPr>
+        <p:spPr>
+          <a:xfrm>
+            <a:off x="777240" y="5724144"/>
+            <a:ext cx="10634472" cy="329184"/>
+          </a:xfrm>
+          <a:prstGeom prst="rect">
+            <a:avLst/>
+          </a:prstGeom>
+          <a:noFill/>
+          <a:ln/>
+        </p:spPr>
+        <p:txBody>
+          <a:bodyPr wrap="square" lIns="0" tIns="0" rIns="0" bIns="0" rtlCol="0" anchor="ctr">
+            <a:normAutofit/>
+          </a:bodyPr>
+          <a:lstStyle/>
+          <a:p>
+            <a:pPr algn="ctr" indent="0" marL="0">
+              <a:lnSpc>
+                <a:spcPct val="100000"/>
+              </a:lnSpc>
+              <a:buNone/>
+            </a:pPr>
+            <a:r>
+              <a:rPr lang="en-US" sz="1100" b="1" dirty="0">
+                <a:solidFill>
+                  <a:srgbClr val="FFFFFF"/>
+                </a:solidFill>
+                <a:latin typeface="Aptos" pitchFamily="34" charset="0"/>
+                <a:ea typeface="Aptos" pitchFamily="34" charset="-122"/>
+                <a:cs typeface="Aptos" pitchFamily="34" charset="-120"/>
+              </a:rPr>
+              <a:t>Không có cảnh báo xử trí/liều lượng nào lọt qua tầng guardrail trong toàn bộ 135 case kiểm tra — kể cả câu diễn đạt gián tiếp.</a:t>
+            </a:r>
+            <a:endParaRPr lang="en-US" sz="1100" dirty="0"/>
           </a:p>
         </p:txBody>
       </p:sp>
@@ -5958,6 +6420,1578 @@
 <file path=ppt/slides/slide12.xml><?xml version="1.0" encoding="utf-8"?>
 <p:sld xmlns:a="http://schemas.openxmlformats.org/drawingml/2006/main" xmlns:r="http://schemas.openxmlformats.org/officeDocument/2006/relationships" xmlns:p="http://schemas.openxmlformats.org/presentationml/2006/main">
   <p:cSld name="Slide 12">
+    <p:spTree>
+      <p:nvGrpSpPr>
+        <p:cNvPr id="1" name=""/>
+        <p:cNvGrpSpPr/>
+        <p:nvPr/>
+      </p:nvGrpSpPr>
+      <p:grpSpPr>
+        <a:xfrm>
+          <a:off x="0" y="0"/>
+          <a:ext cx="0" cy="0"/>
+          <a:chOff x="0" y="0"/>
+          <a:chExt cx="0" cy="0"/>
+        </a:xfrm>
+      </p:grpSpPr>
+      <p:sp>
+        <p:nvSpPr>
+          <p:cNvPr id="2" name="Text 0"/>
+          <p:cNvSpPr txBox="1"/>
+          <p:nvPr/>
+        </p:nvSpPr>
+        <p:spPr>
+          <a:xfrm>
+            <a:off x="530352" y="310896"/>
+            <a:ext cx="4754880" cy="256032"/>
+          </a:xfrm>
+          <a:prstGeom prst="rect">
+            <a:avLst/>
+          </a:prstGeom>
+          <a:noFill/>
+          <a:ln/>
+        </p:spPr>
+        <p:txBody>
+          <a:bodyPr wrap="square" lIns="0" tIns="0" rIns="0" bIns="0" rtlCol="0" anchor="ctr">
+            <a:normAutofit/>
+          </a:bodyPr>
+          <a:lstStyle/>
+          <a:p>
+            <a:pPr algn="l" indent="0" marL="0">
+              <a:lnSpc>
+                <a:spcPct val="100000"/>
+              </a:lnSpc>
+              <a:buNone/>
+            </a:pPr>
+            <a:r>
+              <a:rPr lang="en-US" sz="1000" b="1" spc="180" kern="0" dirty="0">
+                <a:solidFill>
+                  <a:srgbClr val="4D73C9"/>
+                </a:solidFill>
+                <a:latin typeface="Aptos" pitchFamily="34" charset="0"/>
+                <a:ea typeface="Aptos" pitchFamily="34" charset="-122"/>
+                <a:cs typeface="Aptos" pitchFamily="34" charset="-120"/>
+              </a:rPr>
+              <a:t>10 / PHÂN TÍCH &amp; ĐỊNH HƯỚNG</a:t>
+            </a:r>
+            <a:endParaRPr lang="en-US" sz="1000" dirty="0"/>
+          </a:p>
+        </p:txBody>
+      </p:sp>
+      <p:sp>
+        <p:nvSpPr>
+          <p:cNvPr id="3" name="Text 1"/>
+          <p:cNvSpPr txBox="1"/>
+          <p:nvPr/>
+        </p:nvSpPr>
+        <p:spPr>
+          <a:xfrm>
+            <a:off x="530352" y="658368"/>
+            <a:ext cx="11064240" cy="530352"/>
+          </a:xfrm>
+          <a:prstGeom prst="rect">
+            <a:avLst/>
+          </a:prstGeom>
+          <a:noFill/>
+          <a:ln/>
+        </p:spPr>
+        <p:txBody>
+          <a:bodyPr wrap="square" lIns="0" tIns="0" rIns="0" bIns="0" rtlCol="0" anchor="ctr">
+            <a:normAutofit/>
+          </a:bodyPr>
+          <a:lstStyle/>
+          <a:p>
+            <a:pPr algn="l" indent="0" marL="0">
+              <a:lnSpc>
+                <a:spcPct val="100000"/>
+              </a:lnSpc>
+              <a:buNone/>
+            </a:pPr>
+            <a:r>
+              <a:rPr lang="en-US" sz="2700" b="1" dirty="0">
+                <a:solidFill>
+                  <a:srgbClr val="11284C"/>
+                </a:solidFill>
+                <a:latin typeface="Aptos" pitchFamily="34" charset="0"/>
+                <a:ea typeface="Aptos" pitchFamily="34" charset="-122"/>
+                <a:cs typeface="Aptos" pitchFamily="34" charset="-120"/>
+              </a:rPr>
+              <a:t>Nền tảng đúng hướng; bước tiếp theo là chứng minh chất lượng ngoài phòng lab</a:t>
+            </a:r>
+            <a:endParaRPr lang="en-US" sz="2700" dirty="0"/>
+          </a:p>
+        </p:txBody>
+      </p:sp>
+      <p:sp>
+        <p:nvSpPr>
+          <p:cNvPr id="4" name="Text 2"/>
+          <p:cNvSpPr txBox="1"/>
+          <p:nvPr/>
+        </p:nvSpPr>
+        <p:spPr>
+          <a:xfrm>
+            <a:off x="530352" y="1197864"/>
+            <a:ext cx="10972800" cy="384048"/>
+          </a:xfrm>
+          <a:prstGeom prst="rect">
+            <a:avLst/>
+          </a:prstGeom>
+          <a:noFill/>
+          <a:ln/>
+        </p:spPr>
+        <p:txBody>
+          <a:bodyPr wrap="square" lIns="0" tIns="0" rIns="0" bIns="0" rtlCol="0" anchor="ctr">
+            <a:normAutofit/>
+          </a:bodyPr>
+          <a:lstStyle/>
+          <a:p>
+            <a:pPr algn="l" indent="0" marL="0">
+              <a:lnSpc>
+                <a:spcPct val="100000"/>
+              </a:lnSpc>
+              <a:buNone/>
+            </a:pPr>
+            <a:r>
+              <a:rPr lang="en-US" sz="1250" dirty="0">
+                <a:solidFill>
+                  <a:srgbClr val="667792"/>
+                </a:solidFill>
+                <a:latin typeface="Aptos" pitchFamily="34" charset="0"/>
+                <a:ea typeface="Aptos" pitchFamily="34" charset="-122"/>
+                <a:cs typeface="Aptos" pitchFamily="34" charset="-120"/>
+              </a:rPr>
+              <a:t>Roadmap ưu tiên bằng chứng đo lường, độ tin cậy dữ liệu và khả năng vận hành trước khi mở rộng tính năng.</a:t>
+            </a:r>
+            <a:endParaRPr lang="en-US" sz="1250" dirty="0"/>
+          </a:p>
+        </p:txBody>
+      </p:sp>
+      <p:sp>
+        <p:nvSpPr>
+          <p:cNvPr id="5" name="Shape 3"/>
+          <p:cNvSpPr/>
+          <p:nvPr/>
+        </p:nvSpPr>
+        <p:spPr>
+          <a:xfrm>
+            <a:off x="530352" y="1719072"/>
+            <a:ext cx="2505456" cy="1682496"/>
+          </a:xfrm>
+          <a:prstGeom prst="roundRect">
+            <a:avLst>
+              <a:gd name="adj" fmla="val 9239"/>
+            </a:avLst>
+          </a:prstGeom>
+          <a:solidFill>
+            <a:srgbClr val="000000"/>
+          </a:solidFill>
+          <a:ln w="12700">
+            <a:solidFill>
+              <a:srgbClr val="333333"/>
+            </a:solidFill>
+            <a:prstDash val="solid"/>
+          </a:ln>
+        </p:spPr>
+      </p:sp>
+      <p:sp>
+        <p:nvSpPr>
+          <p:cNvPr id="6" name="Text 4"/>
+          <p:cNvSpPr txBox="1"/>
+          <p:nvPr/>
+        </p:nvSpPr>
+        <p:spPr>
+          <a:xfrm>
+            <a:off x="731520" y="1929384"/>
+            <a:ext cx="2103120" cy="246888"/>
+          </a:xfrm>
+          <a:prstGeom prst="rect">
+            <a:avLst/>
+          </a:prstGeom>
+          <a:noFill/>
+          <a:ln/>
+        </p:spPr>
+        <p:txBody>
+          <a:bodyPr wrap="square" lIns="0" tIns="0" rIns="0" bIns="0" rtlCol="0" anchor="ctr">
+            <a:normAutofit/>
+          </a:bodyPr>
+          <a:lstStyle/>
+          <a:p>
+            <a:pPr algn="ctr" indent="0" marL="0">
+              <a:lnSpc>
+                <a:spcPct val="100000"/>
+              </a:lnSpc>
+              <a:buNone/>
+            </a:pPr>
+            <a:r>
+              <a:rPr lang="en-US" sz="1020" b="1" spc="80" kern="0" dirty="0">
+                <a:solidFill>
+                  <a:srgbClr val="E1F5EF"/>
+                </a:solidFill>
+                <a:latin typeface="Aptos" pitchFamily="34" charset="0"/>
+                <a:ea typeface="Aptos" pitchFamily="34" charset="-122"/>
+                <a:cs typeface="Aptos" pitchFamily="34" charset="-120"/>
+              </a:rPr>
+              <a:t>ĐIỂM MẠNH</a:t>
+            </a:r>
+            <a:endParaRPr lang="en-US" sz="1020" dirty="0"/>
+          </a:p>
+        </p:txBody>
+      </p:sp>
+      <p:sp>
+        <p:nvSpPr>
+          <p:cNvPr id="7" name="Text 5"/>
+          <p:cNvSpPr txBox="1"/>
+          <p:nvPr/>
+        </p:nvSpPr>
+        <p:spPr>
+          <a:xfrm>
+            <a:off x="749808" y="2350008"/>
+            <a:ext cx="2066544" cy="786384"/>
+          </a:xfrm>
+          <a:prstGeom prst="rect">
+            <a:avLst/>
+          </a:prstGeom>
+          <a:noFill/>
+          <a:ln/>
+        </p:spPr>
+        <p:txBody>
+          <a:bodyPr wrap="square" lIns="0" tIns="0" rIns="0" bIns="0" rtlCol="0" anchor="t">
+            <a:normAutofit/>
+          </a:bodyPr>
+          <a:lstStyle/>
+          <a:p>
+            <a:pPr algn="ctr" indent="0" marL="0">
+              <a:lnSpc>
+                <a:spcPct val="100000"/>
+              </a:lnSpc>
+              <a:buNone/>
+            </a:pPr>
+            <a:r>
+              <a:rPr lang="en-US" sz="1050" dirty="0">
+                <a:solidFill>
+                  <a:srgbClr val="253B5F"/>
+                </a:solidFill>
+                <a:latin typeface="Aptos" pitchFamily="34" charset="0"/>
+                <a:ea typeface="Aptos" pitchFamily="34" charset="-122"/>
+                <a:cs typeface="Aptos" pitchFamily="34" charset="-120"/>
+              </a:rPr>
+              <a:t>Dữ liệu DDInter thật</a:t>
+            </a:r>
+            <a:endParaRPr lang="en-US" sz="1050" dirty="0"/>
+          </a:p>
+          <a:p>
+            <a:pPr algn="ctr" indent="0" marL="0">
+              <a:lnSpc>
+                <a:spcPct val="100000"/>
+              </a:lnSpc>
+              <a:buNone/>
+            </a:pPr>
+            <a:r>
+              <a:rPr lang="en-US" sz="1050" dirty="0">
+                <a:solidFill>
+                  <a:srgbClr val="253B5F"/>
+                </a:solidFill>
+                <a:latin typeface="Aptos" pitchFamily="34" charset="0"/>
+                <a:ea typeface="Aptos" pitchFamily="34" charset="-122"/>
+                <a:cs typeface="Aptos" pitchFamily="34" charset="-120"/>
+              </a:rPr>
+              <a:t>Giải thích tiếng Việt</a:t>
+            </a:r>
+            <a:endParaRPr lang="en-US" sz="1050" dirty="0"/>
+          </a:p>
+          <a:p>
+            <a:pPr algn="ctr" indent="0" marL="0">
+              <a:lnSpc>
+                <a:spcPct val="100000"/>
+              </a:lnSpc>
+              <a:buNone/>
+            </a:pPr>
+            <a:r>
+              <a:rPr lang="en-US" sz="1050" dirty="0">
+                <a:solidFill>
+                  <a:srgbClr val="253B5F"/>
+                </a:solidFill>
+                <a:latin typeface="Aptos" pitchFamily="34" charset="0"/>
+                <a:ea typeface="Aptos" pitchFamily="34" charset="-122"/>
+                <a:cs typeface="Aptos" pitchFamily="34" charset="-120"/>
+              </a:rPr>
+              <a:t>HITL dược sĩ</a:t>
+            </a:r>
+            <a:endParaRPr lang="en-US" sz="1050" dirty="0"/>
+          </a:p>
+        </p:txBody>
+      </p:sp>
+      <p:sp>
+        <p:nvSpPr>
+          <p:cNvPr id="8" name="Shape 6"/>
+          <p:cNvSpPr/>
+          <p:nvPr/>
+        </p:nvSpPr>
+        <p:spPr>
+          <a:xfrm>
+            <a:off x="3319272" y="1719072"/>
+            <a:ext cx="2505456" cy="1682496"/>
+          </a:xfrm>
+          <a:prstGeom prst="roundRect">
+            <a:avLst>
+              <a:gd name="adj" fmla="val 9239"/>
+            </a:avLst>
+          </a:prstGeom>
+          <a:solidFill>
+            <a:srgbClr val="000000"/>
+          </a:solidFill>
+          <a:ln w="12700">
+            <a:solidFill>
+              <a:srgbClr val="333333"/>
+            </a:solidFill>
+            <a:prstDash val="solid"/>
+          </a:ln>
+        </p:spPr>
+      </p:sp>
+      <p:sp>
+        <p:nvSpPr>
+          <p:cNvPr id="9" name="Text 7"/>
+          <p:cNvSpPr txBox="1"/>
+          <p:nvPr/>
+        </p:nvSpPr>
+        <p:spPr>
+          <a:xfrm>
+            <a:off x="3520440" y="1929384"/>
+            <a:ext cx="2103120" cy="246888"/>
+          </a:xfrm>
+          <a:prstGeom prst="rect">
+            <a:avLst/>
+          </a:prstGeom>
+          <a:noFill/>
+          <a:ln/>
+        </p:spPr>
+        <p:txBody>
+          <a:bodyPr wrap="square" lIns="0" tIns="0" rIns="0" bIns="0" rtlCol="0" anchor="ctr">
+            <a:normAutofit/>
+          </a:bodyPr>
+          <a:lstStyle/>
+          <a:p>
+            <a:pPr algn="ctr" indent="0" marL="0">
+              <a:lnSpc>
+                <a:spcPct val="100000"/>
+              </a:lnSpc>
+              <a:buNone/>
+            </a:pPr>
+            <a:r>
+              <a:rPr lang="en-US" sz="1020" b="1" spc="80" kern="0" dirty="0">
+                <a:solidFill>
+                  <a:srgbClr val="FFE5E2"/>
+                </a:solidFill>
+                <a:latin typeface="Aptos" pitchFamily="34" charset="0"/>
+                <a:ea typeface="Aptos" pitchFamily="34" charset="-122"/>
+                <a:cs typeface="Aptos" pitchFamily="34" charset="-120"/>
+              </a:rPr>
+              <a:t>ĐIỂM YẾU</a:t>
+            </a:r>
+            <a:endParaRPr lang="en-US" sz="1020" dirty="0"/>
+          </a:p>
+        </p:txBody>
+      </p:sp>
+      <p:sp>
+        <p:nvSpPr>
+          <p:cNvPr id="10" name="Text 8"/>
+          <p:cNvSpPr txBox="1"/>
+          <p:nvPr/>
+        </p:nvSpPr>
+        <p:spPr>
+          <a:xfrm>
+            <a:off x="3538728" y="2350008"/>
+            <a:ext cx="2066544" cy="786384"/>
+          </a:xfrm>
+          <a:prstGeom prst="rect">
+            <a:avLst/>
+          </a:prstGeom>
+          <a:noFill/>
+          <a:ln/>
+        </p:spPr>
+        <p:txBody>
+          <a:bodyPr wrap="square" lIns="0" tIns="0" rIns="0" bIns="0" rtlCol="0" anchor="t">
+            <a:normAutofit/>
+          </a:bodyPr>
+          <a:lstStyle/>
+          <a:p>
+            <a:pPr algn="ctr" indent="0" marL="0">
+              <a:lnSpc>
+                <a:spcPct val="100000"/>
+              </a:lnSpc>
+              <a:buNone/>
+            </a:pPr>
+            <a:r>
+              <a:rPr lang="en-US" sz="1050" dirty="0">
+                <a:solidFill>
+                  <a:srgbClr val="253B5F"/>
+                </a:solidFill>
+                <a:latin typeface="Aptos" pitchFamily="34" charset="0"/>
+                <a:ea typeface="Aptos" pitchFamily="34" charset="-122"/>
+                <a:cs typeface="Aptos" pitchFamily="34" charset="-120"/>
+              </a:rPr>
+              <a:t>KPI chưa đo đủ</a:t>
+            </a:r>
+            <a:endParaRPr lang="en-US" sz="1050" dirty="0"/>
+          </a:p>
+          <a:p>
+            <a:pPr algn="ctr" indent="0" marL="0">
+              <a:lnSpc>
+                <a:spcPct val="100000"/>
+              </a:lnSpc>
+              <a:buNone/>
+            </a:pPr>
+            <a:r>
+              <a:rPr lang="en-US" sz="1050" dirty="0">
+                <a:solidFill>
+                  <a:srgbClr val="253B5F"/>
+                </a:solidFill>
+                <a:latin typeface="Aptos" pitchFamily="34" charset="0"/>
+                <a:ea typeface="Aptos" pitchFamily="34" charset="-122"/>
+                <a:cs typeface="Aptos" pitchFamily="34" charset="-120"/>
+              </a:rPr>
+              <a:t>Phụ thuộc dịch vụ LLM</a:t>
+            </a:r>
+            <a:endParaRPr lang="en-US" sz="1050" dirty="0"/>
+          </a:p>
+          <a:p>
+            <a:pPr algn="ctr" indent="0" marL="0">
+              <a:lnSpc>
+                <a:spcPct val="100000"/>
+              </a:lnSpc>
+              <a:buNone/>
+            </a:pPr>
+            <a:r>
+              <a:rPr lang="en-US" sz="1050" dirty="0">
+                <a:solidFill>
+                  <a:srgbClr val="253B5F"/>
+                </a:solidFill>
+                <a:latin typeface="Aptos" pitchFamily="34" charset="0"/>
+                <a:ea typeface="Aptos" pitchFamily="34" charset="-122"/>
+                <a:cs typeface="Aptos" pitchFamily="34" charset="-120"/>
+              </a:rPr>
+              <a:t>Dữ liệu y tế nhạy cảm</a:t>
+            </a:r>
+            <a:endParaRPr lang="en-US" sz="1050" dirty="0"/>
+          </a:p>
+        </p:txBody>
+      </p:sp>
+      <p:sp>
+        <p:nvSpPr>
+          <p:cNvPr id="11" name="Shape 9"/>
+          <p:cNvSpPr/>
+          <p:nvPr/>
+        </p:nvSpPr>
+        <p:spPr>
+          <a:xfrm>
+            <a:off x="6108192" y="1719072"/>
+            <a:ext cx="2505456" cy="1682496"/>
+          </a:xfrm>
+          <a:prstGeom prst="roundRect">
+            <a:avLst>
+              <a:gd name="adj" fmla="val 9239"/>
+            </a:avLst>
+          </a:prstGeom>
+          <a:solidFill>
+            <a:srgbClr val="000000"/>
+          </a:solidFill>
+          <a:ln w="12700">
+            <a:solidFill>
+              <a:srgbClr val="333333"/>
+            </a:solidFill>
+            <a:prstDash val="solid"/>
+          </a:ln>
+        </p:spPr>
+      </p:sp>
+      <p:sp>
+        <p:nvSpPr>
+          <p:cNvPr id="12" name="Text 10"/>
+          <p:cNvSpPr txBox="1"/>
+          <p:nvPr/>
+        </p:nvSpPr>
+        <p:spPr>
+          <a:xfrm>
+            <a:off x="6309360" y="1929384"/>
+            <a:ext cx="2103120" cy="246888"/>
+          </a:xfrm>
+          <a:prstGeom prst="rect">
+            <a:avLst/>
+          </a:prstGeom>
+          <a:noFill/>
+          <a:ln/>
+        </p:spPr>
+        <p:txBody>
+          <a:bodyPr wrap="square" lIns="0" tIns="0" rIns="0" bIns="0" rtlCol="0" anchor="ctr">
+            <a:normAutofit/>
+          </a:bodyPr>
+          <a:lstStyle/>
+          <a:p>
+            <a:pPr algn="ctr" indent="0" marL="0">
+              <a:lnSpc>
+                <a:spcPct val="100000"/>
+              </a:lnSpc>
+              <a:buNone/>
+            </a:pPr>
+            <a:r>
+              <a:rPr lang="en-US" sz="1020" b="1" spc="80" kern="0" dirty="0">
+                <a:solidFill>
+                  <a:srgbClr val="E9F0FF"/>
+                </a:solidFill>
+                <a:latin typeface="Aptos" pitchFamily="34" charset="0"/>
+                <a:ea typeface="Aptos" pitchFamily="34" charset="-122"/>
+                <a:cs typeface="Aptos" pitchFamily="34" charset="-120"/>
+              </a:rPr>
+              <a:t>CƠ HỘI</a:t>
+            </a:r>
+            <a:endParaRPr lang="en-US" sz="1020" dirty="0"/>
+          </a:p>
+        </p:txBody>
+      </p:sp>
+      <p:sp>
+        <p:nvSpPr>
+          <p:cNvPr id="13" name="Text 11"/>
+          <p:cNvSpPr txBox="1"/>
+          <p:nvPr/>
+        </p:nvSpPr>
+        <p:spPr>
+          <a:xfrm>
+            <a:off x="6327648" y="2350008"/>
+            <a:ext cx="2066544" cy="786384"/>
+          </a:xfrm>
+          <a:prstGeom prst="rect">
+            <a:avLst/>
+          </a:prstGeom>
+          <a:noFill/>
+          <a:ln/>
+        </p:spPr>
+        <p:txBody>
+          <a:bodyPr wrap="square" lIns="0" tIns="0" rIns="0" bIns="0" rtlCol="0" anchor="t">
+            <a:normAutofit/>
+          </a:bodyPr>
+          <a:lstStyle/>
+          <a:p>
+            <a:pPr algn="ctr" indent="0" marL="0">
+              <a:lnSpc>
+                <a:spcPct val="100000"/>
+              </a:lnSpc>
+              <a:buNone/>
+            </a:pPr>
+            <a:r>
+              <a:rPr lang="en-US" sz="1050" dirty="0">
+                <a:solidFill>
+                  <a:srgbClr val="253B5F"/>
+                </a:solidFill>
+                <a:latin typeface="Aptos" pitchFamily="34" charset="0"/>
+                <a:ea typeface="Aptos" pitchFamily="34" charset="-122"/>
+                <a:cs typeface="Aptos" pitchFamily="34" charset="-120"/>
+              </a:rPr>
+              <a:t>Nhà thuốc / phòng khám nhỏ</a:t>
+            </a:r>
+            <a:endParaRPr lang="en-US" sz="1050" dirty="0"/>
+          </a:p>
+          <a:p>
+            <a:pPr algn="ctr" indent="0" marL="0">
+              <a:lnSpc>
+                <a:spcPct val="100000"/>
+              </a:lnSpc>
+              <a:buNone/>
+            </a:pPr>
+            <a:r>
+              <a:rPr lang="en-US" sz="1050" dirty="0">
+                <a:solidFill>
+                  <a:srgbClr val="253B5F"/>
+                </a:solidFill>
+                <a:latin typeface="Aptos" pitchFamily="34" charset="0"/>
+                <a:ea typeface="Aptos" pitchFamily="34" charset="-122"/>
+                <a:cs typeface="Aptos" pitchFamily="34" charset="-120"/>
+              </a:rPr>
+              <a:t>Người dùng đa bệnh lý</a:t>
+            </a:r>
+            <a:endParaRPr lang="en-US" sz="1050" dirty="0"/>
+          </a:p>
+          <a:p>
+            <a:pPr algn="ctr" indent="0" marL="0">
+              <a:lnSpc>
+                <a:spcPct val="100000"/>
+              </a:lnSpc>
+              <a:buNone/>
+            </a:pPr>
+            <a:r>
+              <a:rPr lang="en-US" sz="1050" dirty="0">
+                <a:solidFill>
+                  <a:srgbClr val="253B5F"/>
+                </a:solidFill>
+                <a:latin typeface="Aptos" pitchFamily="34" charset="0"/>
+                <a:ea typeface="Aptos" pitchFamily="34" charset="-122"/>
+                <a:cs typeface="Aptos" pitchFamily="34" charset="-120"/>
+              </a:rPr>
+              <a:t>OCR đơn thuốc</a:t>
+            </a:r>
+            <a:endParaRPr lang="en-US" sz="1050" dirty="0"/>
+          </a:p>
+        </p:txBody>
+      </p:sp>
+      <p:sp>
+        <p:nvSpPr>
+          <p:cNvPr id="14" name="Shape 12"/>
+          <p:cNvSpPr/>
+          <p:nvPr/>
+        </p:nvSpPr>
+        <p:spPr>
+          <a:xfrm>
+            <a:off x="8897112" y="1719072"/>
+            <a:ext cx="2505456" cy="1682496"/>
+          </a:xfrm>
+          <a:prstGeom prst="roundRect">
+            <a:avLst>
+              <a:gd name="adj" fmla="val 9239"/>
+            </a:avLst>
+          </a:prstGeom>
+          <a:solidFill>
+            <a:srgbClr val="000000"/>
+          </a:solidFill>
+          <a:ln w="12700">
+            <a:solidFill>
+              <a:srgbClr val="333333"/>
+            </a:solidFill>
+            <a:prstDash val="solid"/>
+          </a:ln>
+        </p:spPr>
+      </p:sp>
+      <p:sp>
+        <p:nvSpPr>
+          <p:cNvPr id="15" name="Text 13"/>
+          <p:cNvSpPr txBox="1"/>
+          <p:nvPr/>
+        </p:nvSpPr>
+        <p:spPr>
+          <a:xfrm>
+            <a:off x="9098280" y="1929384"/>
+            <a:ext cx="2103120" cy="246888"/>
+          </a:xfrm>
+          <a:prstGeom prst="rect">
+            <a:avLst/>
+          </a:prstGeom>
+          <a:noFill/>
+          <a:ln/>
+        </p:spPr>
+        <p:txBody>
+          <a:bodyPr wrap="square" lIns="0" tIns="0" rIns="0" bIns="0" rtlCol="0" anchor="ctr">
+            <a:normAutofit/>
+          </a:bodyPr>
+          <a:lstStyle/>
+          <a:p>
+            <a:pPr algn="ctr" indent="0" marL="0">
+              <a:lnSpc>
+                <a:spcPct val="100000"/>
+              </a:lnSpc>
+              <a:buNone/>
+            </a:pPr>
+            <a:r>
+              <a:rPr lang="en-US" sz="1020" b="1" spc="80" kern="0" dirty="0">
+                <a:solidFill>
+                  <a:srgbClr val="FFF1D9"/>
+                </a:solidFill>
+                <a:latin typeface="Aptos" pitchFamily="34" charset="0"/>
+                <a:ea typeface="Aptos" pitchFamily="34" charset="-122"/>
+                <a:cs typeface="Aptos" pitchFamily="34" charset="-120"/>
+              </a:rPr>
+              <a:t>THÁCH THỨC</a:t>
+            </a:r>
+            <a:endParaRPr lang="en-US" sz="1020" dirty="0"/>
+          </a:p>
+        </p:txBody>
+      </p:sp>
+      <p:sp>
+        <p:nvSpPr>
+          <p:cNvPr id="16" name="Text 14"/>
+          <p:cNvSpPr txBox="1"/>
+          <p:nvPr/>
+        </p:nvSpPr>
+        <p:spPr>
+          <a:xfrm>
+            <a:off x="9116568" y="2350008"/>
+            <a:ext cx="2066544" cy="786384"/>
+          </a:xfrm>
+          <a:prstGeom prst="rect">
+            <a:avLst/>
+          </a:prstGeom>
+          <a:noFill/>
+          <a:ln/>
+        </p:spPr>
+        <p:txBody>
+          <a:bodyPr wrap="square" lIns="0" tIns="0" rIns="0" bIns="0" rtlCol="0" anchor="t">
+            <a:normAutofit/>
+          </a:bodyPr>
+          <a:lstStyle/>
+          <a:p>
+            <a:pPr algn="ctr" indent="0" marL="0">
+              <a:lnSpc>
+                <a:spcPct val="100000"/>
+              </a:lnSpc>
+              <a:buNone/>
+            </a:pPr>
+            <a:r>
+              <a:rPr lang="en-US" sz="1050" dirty="0">
+                <a:solidFill>
+                  <a:srgbClr val="253B5F"/>
+                </a:solidFill>
+                <a:latin typeface="Aptos" pitchFamily="34" charset="0"/>
+                <a:ea typeface="Aptos" pitchFamily="34" charset="-122"/>
+                <a:cs typeface="Aptos" pitchFamily="34" charset="-120"/>
+              </a:rPr>
+              <a:t>Niềm tin &amp; pháp lý</a:t>
+            </a:r>
+            <a:endParaRPr lang="en-US" sz="1050" dirty="0"/>
+          </a:p>
+          <a:p>
+            <a:pPr algn="ctr" indent="0" marL="0">
+              <a:lnSpc>
+                <a:spcPct val="100000"/>
+              </a:lnSpc>
+              <a:buNone/>
+            </a:pPr>
+            <a:r>
+              <a:rPr lang="en-US" sz="1050" dirty="0">
+                <a:solidFill>
+                  <a:srgbClr val="253B5F"/>
+                </a:solidFill>
+                <a:latin typeface="Aptos" pitchFamily="34" charset="0"/>
+                <a:ea typeface="Aptos" pitchFamily="34" charset="-122"/>
+                <a:cs typeface="Aptos" pitchFamily="34" charset="-120"/>
+              </a:rPr>
+              <a:t>Duy trì dữ liệu cập nhật</a:t>
+            </a:r>
+            <a:endParaRPr lang="en-US" sz="1050" dirty="0"/>
+          </a:p>
+          <a:p>
+            <a:pPr algn="ctr" indent="0" marL="0">
+              <a:lnSpc>
+                <a:spcPct val="100000"/>
+              </a:lnSpc>
+              <a:buNone/>
+            </a:pPr>
+            <a:r>
+              <a:rPr lang="en-US" sz="1050" dirty="0">
+                <a:solidFill>
+                  <a:srgbClr val="253B5F"/>
+                </a:solidFill>
+                <a:latin typeface="Aptos" pitchFamily="34" charset="0"/>
+                <a:ea typeface="Aptos" pitchFamily="34" charset="-122"/>
+                <a:cs typeface="Aptos" pitchFamily="34" charset="-120"/>
+              </a:rPr>
+              <a:t>Trách nhiệm khi cảnh báo sai</a:t>
+            </a:r>
+            <a:endParaRPr lang="en-US" sz="1050" dirty="0"/>
+          </a:p>
+        </p:txBody>
+      </p:sp>
+      <p:sp>
+        <p:nvSpPr>
+          <p:cNvPr id="17" name="Text 15"/>
+          <p:cNvSpPr txBox="1"/>
+          <p:nvPr/>
+        </p:nvSpPr>
+        <p:spPr>
+          <a:xfrm>
+            <a:off x="530352" y="3794760"/>
+            <a:ext cx="2194560" cy="256032"/>
+          </a:xfrm>
+          <a:prstGeom prst="rect">
+            <a:avLst/>
+          </a:prstGeom>
+          <a:noFill/>
+          <a:ln/>
+        </p:spPr>
+        <p:txBody>
+          <a:bodyPr wrap="square" lIns="0" tIns="0" rIns="0" bIns="0" rtlCol="0" anchor="ctr">
+            <a:normAutofit/>
+          </a:bodyPr>
+          <a:lstStyle/>
+          <a:p>
+            <a:pPr algn="l" indent="0" marL="0">
+              <a:lnSpc>
+                <a:spcPct val="100000"/>
+              </a:lnSpc>
+              <a:buNone/>
+            </a:pPr>
+            <a:r>
+              <a:rPr lang="en-US" sz="1000" b="1" spc="120" kern="0" dirty="0">
+                <a:solidFill>
+                  <a:srgbClr val="4D73C9"/>
+                </a:solidFill>
+                <a:latin typeface="Aptos" pitchFamily="34" charset="0"/>
+                <a:ea typeface="Aptos" pitchFamily="34" charset="-122"/>
+                <a:cs typeface="Aptos" pitchFamily="34" charset="-120"/>
+              </a:rPr>
+              <a:t>ROADMAP ĐỀ XUẤT</a:t>
+            </a:r>
+            <a:endParaRPr lang="en-US" sz="1000" dirty="0"/>
+          </a:p>
+        </p:txBody>
+      </p:sp>
+      <p:sp>
+        <p:nvSpPr>
+          <p:cNvPr id="18" name="Shape 16"/>
+          <p:cNvSpPr/>
+          <p:nvPr/>
+        </p:nvSpPr>
+        <p:spPr>
+          <a:xfrm>
+            <a:off x="530352" y="4315968"/>
+            <a:ext cx="429768" cy="429768"/>
+          </a:xfrm>
+          <a:prstGeom prst="ellipse">
+            <a:avLst/>
+          </a:prstGeom>
+          <a:solidFill>
+            <a:srgbClr val="4D73C9"/>
+          </a:solidFill>
+          <a:ln w="12700">
+            <a:solidFill>
+              <a:srgbClr val="4D73C9"/>
+            </a:solidFill>
+            <a:prstDash val="solid"/>
+          </a:ln>
+        </p:spPr>
+      </p:sp>
+      <p:sp>
+        <p:nvSpPr>
+          <p:cNvPr id="19" name="Text 17"/>
+          <p:cNvSpPr txBox="1"/>
+          <p:nvPr/>
+        </p:nvSpPr>
+        <p:spPr>
+          <a:xfrm>
+            <a:off x="530352" y="4343400"/>
+            <a:ext cx="429768" cy="310896"/>
+          </a:xfrm>
+          <a:prstGeom prst="rect">
+            <a:avLst/>
+          </a:prstGeom>
+          <a:noFill/>
+          <a:ln/>
+        </p:spPr>
+        <p:txBody>
+          <a:bodyPr wrap="square" lIns="0" tIns="0" rIns="0" bIns="0" rtlCol="0" anchor="ctr">
+            <a:normAutofit/>
+          </a:bodyPr>
+          <a:lstStyle/>
+          <a:p>
+            <a:pPr algn="ctr" indent="0" marL="0">
+              <a:lnSpc>
+                <a:spcPct val="100000"/>
+              </a:lnSpc>
+              <a:buNone/>
+            </a:pPr>
+            <a:r>
+              <a:rPr lang="en-US" sz="920" b="1" dirty="0">
+                <a:solidFill>
+                  <a:srgbClr val="FFFFFF"/>
+                </a:solidFill>
+                <a:latin typeface="Aptos" pitchFamily="34" charset="0"/>
+                <a:ea typeface="Aptos" pitchFamily="34" charset="-122"/>
+                <a:cs typeface="Aptos" pitchFamily="34" charset="-120"/>
+              </a:rPr>
+              <a:t>01</a:t>
+            </a:r>
+            <a:endParaRPr lang="en-US" sz="920" dirty="0"/>
+          </a:p>
+        </p:txBody>
+      </p:sp>
+      <p:sp>
+        <p:nvSpPr>
+          <p:cNvPr id="20" name="Shape 18"/>
+          <p:cNvSpPr/>
+          <p:nvPr/>
+        </p:nvSpPr>
+        <p:spPr>
+          <a:xfrm>
+            <a:off x="1005840" y="4535424"/>
+            <a:ext cx="2103120" cy="0"/>
+          </a:xfrm>
+          <a:prstGeom prst="line">
+            <a:avLst/>
+          </a:prstGeom>
+          <a:noFill/>
+          <a:ln w="17780">
+            <a:solidFill>
+              <a:srgbClr val="CBD8ED"/>
+            </a:solidFill>
+            <a:prstDash val="solid"/>
+            <a:headEnd type="none"/>
+            <a:tailEnd type="triangle"/>
+          </a:ln>
+        </p:spPr>
+      </p:sp>
+      <p:sp>
+        <p:nvSpPr>
+          <p:cNvPr id="21" name="Text 19"/>
+          <p:cNvSpPr txBox="1"/>
+          <p:nvPr/>
+        </p:nvSpPr>
+        <p:spPr>
+          <a:xfrm>
+            <a:off x="530352" y="4919472"/>
+            <a:ext cx="2487168" cy="256032"/>
+          </a:xfrm>
+          <a:prstGeom prst="rect">
+            <a:avLst/>
+          </a:prstGeom>
+          <a:noFill/>
+          <a:ln/>
+        </p:spPr>
+        <p:txBody>
+          <a:bodyPr wrap="square" lIns="0" tIns="0" rIns="0" bIns="0" rtlCol="0" anchor="ctr">
+            <a:normAutofit/>
+          </a:bodyPr>
+          <a:lstStyle/>
+          <a:p>
+            <a:pPr algn="l" indent="0" marL="0">
+              <a:lnSpc>
+                <a:spcPct val="100000"/>
+              </a:lnSpc>
+              <a:buNone/>
+            </a:pPr>
+            <a:r>
+              <a:rPr lang="en-US" sz="1050" b="1" dirty="0">
+                <a:solidFill>
+                  <a:srgbClr val="11284C"/>
+                </a:solidFill>
+                <a:latin typeface="Aptos" pitchFamily="34" charset="0"/>
+                <a:ea typeface="Aptos" pitchFamily="34" charset="-122"/>
+                <a:cs typeface="Aptos" pitchFamily="34" charset="-120"/>
+              </a:rPr>
+              <a:t>ĐO LƯỜNG</a:t>
+            </a:r>
+            <a:endParaRPr lang="en-US" sz="1050" dirty="0"/>
+          </a:p>
+        </p:txBody>
+      </p:sp>
+      <p:sp>
+        <p:nvSpPr>
+          <p:cNvPr id="22" name="Text 20"/>
+          <p:cNvSpPr txBox="1"/>
+          <p:nvPr/>
+        </p:nvSpPr>
+        <p:spPr>
+          <a:xfrm>
+            <a:off x="530352" y="5294376"/>
+            <a:ext cx="2487168" cy="658368"/>
+          </a:xfrm>
+          <a:prstGeom prst="rect">
+            <a:avLst/>
+          </a:prstGeom>
+          <a:noFill/>
+          <a:ln/>
+        </p:spPr>
+        <p:txBody>
+          <a:bodyPr wrap="square" lIns="0" tIns="0" rIns="0" bIns="0" rtlCol="0" anchor="t">
+            <a:normAutofit/>
+          </a:bodyPr>
+          <a:lstStyle/>
+          <a:p>
+            <a:pPr algn="l" indent="0" marL="0">
+              <a:lnSpc>
+                <a:spcPct val="100000"/>
+              </a:lnSpc>
+              <a:buNone/>
+            </a:pPr>
+            <a:r>
+              <a:rPr lang="en-US" sz="1020" dirty="0">
+                <a:solidFill>
+                  <a:srgbClr val="667792"/>
+                </a:solidFill>
+                <a:latin typeface="Aptos" pitchFamily="34" charset="0"/>
+                <a:ea typeface="Aptos" pitchFamily="34" charset="-122"/>
+                <a:cs typeface="Aptos" pitchFamily="34" charset="-120"/>
+              </a:rPr>
+              <a:t>Bộ test chuẩn; accuracy, latency, citation coverage</a:t>
+            </a:r>
+            <a:endParaRPr lang="en-US" sz="1020" dirty="0"/>
+          </a:p>
+        </p:txBody>
+      </p:sp>
+      <p:sp>
+        <p:nvSpPr>
+          <p:cNvPr id="23" name="Shape 21"/>
+          <p:cNvSpPr/>
+          <p:nvPr/>
+        </p:nvSpPr>
+        <p:spPr>
+          <a:xfrm>
+            <a:off x="3319272" y="4315968"/>
+            <a:ext cx="429768" cy="429768"/>
+          </a:xfrm>
+          <a:prstGeom prst="ellipse">
+            <a:avLst/>
+          </a:prstGeom>
+          <a:solidFill>
+            <a:srgbClr val="4D73C9"/>
+          </a:solidFill>
+          <a:ln w="12700">
+            <a:solidFill>
+              <a:srgbClr val="4D73C9"/>
+            </a:solidFill>
+            <a:prstDash val="solid"/>
+          </a:ln>
+        </p:spPr>
+      </p:sp>
+      <p:sp>
+        <p:nvSpPr>
+          <p:cNvPr id="24" name="Text 22"/>
+          <p:cNvSpPr txBox="1"/>
+          <p:nvPr/>
+        </p:nvSpPr>
+        <p:spPr>
+          <a:xfrm>
+            <a:off x="3319272" y="4343400"/>
+            <a:ext cx="429768" cy="310896"/>
+          </a:xfrm>
+          <a:prstGeom prst="rect">
+            <a:avLst/>
+          </a:prstGeom>
+          <a:noFill/>
+          <a:ln/>
+        </p:spPr>
+        <p:txBody>
+          <a:bodyPr wrap="square" lIns="0" tIns="0" rIns="0" bIns="0" rtlCol="0" anchor="ctr">
+            <a:normAutofit/>
+          </a:bodyPr>
+          <a:lstStyle/>
+          <a:p>
+            <a:pPr algn="ctr" indent="0" marL="0">
+              <a:lnSpc>
+                <a:spcPct val="100000"/>
+              </a:lnSpc>
+              <a:buNone/>
+            </a:pPr>
+            <a:r>
+              <a:rPr lang="en-US" sz="920" b="1" dirty="0">
+                <a:solidFill>
+                  <a:srgbClr val="FFFFFF"/>
+                </a:solidFill>
+                <a:latin typeface="Aptos" pitchFamily="34" charset="0"/>
+                <a:ea typeface="Aptos" pitchFamily="34" charset="-122"/>
+                <a:cs typeface="Aptos" pitchFamily="34" charset="-120"/>
+              </a:rPr>
+              <a:t>02</a:t>
+            </a:r>
+            <a:endParaRPr lang="en-US" sz="920" dirty="0"/>
+          </a:p>
+        </p:txBody>
+      </p:sp>
+      <p:sp>
+        <p:nvSpPr>
+          <p:cNvPr id="25" name="Shape 23"/>
+          <p:cNvSpPr/>
+          <p:nvPr/>
+        </p:nvSpPr>
+        <p:spPr>
+          <a:xfrm>
+            <a:off x="3794760" y="4535424"/>
+            <a:ext cx="2103120" cy="0"/>
+          </a:xfrm>
+          <a:prstGeom prst="line">
+            <a:avLst/>
+          </a:prstGeom>
+          <a:noFill/>
+          <a:ln w="17780">
+            <a:solidFill>
+              <a:srgbClr val="CBD8ED"/>
+            </a:solidFill>
+            <a:prstDash val="solid"/>
+            <a:headEnd type="none"/>
+            <a:tailEnd type="triangle"/>
+          </a:ln>
+        </p:spPr>
+      </p:sp>
+      <p:sp>
+        <p:nvSpPr>
+          <p:cNvPr id="26" name="Text 24"/>
+          <p:cNvSpPr txBox="1"/>
+          <p:nvPr/>
+        </p:nvSpPr>
+        <p:spPr>
+          <a:xfrm>
+            <a:off x="3319272" y="4919472"/>
+            <a:ext cx="2487168" cy="256032"/>
+          </a:xfrm>
+          <a:prstGeom prst="rect">
+            <a:avLst/>
+          </a:prstGeom>
+          <a:noFill/>
+          <a:ln/>
+        </p:spPr>
+        <p:txBody>
+          <a:bodyPr wrap="square" lIns="0" tIns="0" rIns="0" bIns="0" rtlCol="0" anchor="ctr">
+            <a:normAutofit/>
+          </a:bodyPr>
+          <a:lstStyle/>
+          <a:p>
+            <a:pPr algn="l" indent="0" marL="0">
+              <a:lnSpc>
+                <a:spcPct val="100000"/>
+              </a:lnSpc>
+              <a:buNone/>
+            </a:pPr>
+            <a:r>
+              <a:rPr lang="en-US" sz="1050" b="1" dirty="0">
+                <a:solidFill>
+                  <a:srgbClr val="11284C"/>
+                </a:solidFill>
+                <a:latin typeface="Aptos" pitchFamily="34" charset="0"/>
+                <a:ea typeface="Aptos" pitchFamily="34" charset="-122"/>
+                <a:cs typeface="Aptos" pitchFamily="34" charset="-120"/>
+              </a:rPr>
+              <a:t>KIỂM CHỨNG</a:t>
+            </a:r>
+            <a:endParaRPr lang="en-US" sz="1050" dirty="0"/>
+          </a:p>
+        </p:txBody>
+      </p:sp>
+      <p:sp>
+        <p:nvSpPr>
+          <p:cNvPr id="27" name="Text 25"/>
+          <p:cNvSpPr txBox="1"/>
+          <p:nvPr/>
+        </p:nvSpPr>
+        <p:spPr>
+          <a:xfrm>
+            <a:off x="3319272" y="5294376"/>
+            <a:ext cx="2487168" cy="658368"/>
+          </a:xfrm>
+          <a:prstGeom prst="rect">
+            <a:avLst/>
+          </a:prstGeom>
+          <a:noFill/>
+          <a:ln/>
+        </p:spPr>
+        <p:txBody>
+          <a:bodyPr wrap="square" lIns="0" tIns="0" rIns="0" bIns="0" rtlCol="0" anchor="t">
+            <a:normAutofit/>
+          </a:bodyPr>
+          <a:lstStyle/>
+          <a:p>
+            <a:pPr algn="l" indent="0" marL="0">
+              <a:lnSpc>
+                <a:spcPct val="100000"/>
+              </a:lnSpc>
+              <a:buNone/>
+            </a:pPr>
+            <a:r>
+              <a:rPr lang="en-US" sz="1020" dirty="0">
+                <a:solidFill>
+                  <a:srgbClr val="667792"/>
+                </a:solidFill>
+                <a:latin typeface="Aptos" pitchFamily="34" charset="0"/>
+                <a:ea typeface="Aptos" pitchFamily="34" charset="-122"/>
+                <a:cs typeface="Aptos" pitchFamily="34" charset="-120"/>
+              </a:rPr>
+              <a:t>Pilot với dược sĩ; phân tích cảnh báo sai / bỏ sót</a:t>
+            </a:r>
+            <a:endParaRPr lang="en-US" sz="1020" dirty="0"/>
+          </a:p>
+        </p:txBody>
+      </p:sp>
+      <p:sp>
+        <p:nvSpPr>
+          <p:cNvPr id="28" name="Shape 26"/>
+          <p:cNvSpPr/>
+          <p:nvPr/>
+        </p:nvSpPr>
+        <p:spPr>
+          <a:xfrm>
+            <a:off x="6108192" y="4315968"/>
+            <a:ext cx="429768" cy="429768"/>
+          </a:xfrm>
+          <a:prstGeom prst="ellipse">
+            <a:avLst/>
+          </a:prstGeom>
+          <a:solidFill>
+            <a:srgbClr val="4D73C9"/>
+          </a:solidFill>
+          <a:ln w="12700">
+            <a:solidFill>
+              <a:srgbClr val="4D73C9"/>
+            </a:solidFill>
+            <a:prstDash val="solid"/>
+          </a:ln>
+        </p:spPr>
+      </p:sp>
+      <p:sp>
+        <p:nvSpPr>
+          <p:cNvPr id="29" name="Text 27"/>
+          <p:cNvSpPr txBox="1"/>
+          <p:nvPr/>
+        </p:nvSpPr>
+        <p:spPr>
+          <a:xfrm>
+            <a:off x="6108192" y="4343400"/>
+            <a:ext cx="429768" cy="310896"/>
+          </a:xfrm>
+          <a:prstGeom prst="rect">
+            <a:avLst/>
+          </a:prstGeom>
+          <a:noFill/>
+          <a:ln/>
+        </p:spPr>
+        <p:txBody>
+          <a:bodyPr wrap="square" lIns="0" tIns="0" rIns="0" bIns="0" rtlCol="0" anchor="ctr">
+            <a:normAutofit/>
+          </a:bodyPr>
+          <a:lstStyle/>
+          <a:p>
+            <a:pPr algn="ctr" indent="0" marL="0">
+              <a:lnSpc>
+                <a:spcPct val="100000"/>
+              </a:lnSpc>
+              <a:buNone/>
+            </a:pPr>
+            <a:r>
+              <a:rPr lang="en-US" sz="920" b="1" dirty="0">
+                <a:solidFill>
+                  <a:srgbClr val="FFFFFF"/>
+                </a:solidFill>
+                <a:latin typeface="Aptos" pitchFamily="34" charset="0"/>
+                <a:ea typeface="Aptos" pitchFamily="34" charset="-122"/>
+                <a:cs typeface="Aptos" pitchFamily="34" charset="-120"/>
+              </a:rPr>
+              <a:t>03</a:t>
+            </a:r>
+            <a:endParaRPr lang="en-US" sz="920" dirty="0"/>
+          </a:p>
+        </p:txBody>
+      </p:sp>
+      <p:sp>
+        <p:nvSpPr>
+          <p:cNvPr id="30" name="Shape 28"/>
+          <p:cNvSpPr/>
+          <p:nvPr/>
+        </p:nvSpPr>
+        <p:spPr>
+          <a:xfrm>
+            <a:off x="6583680" y="4535424"/>
+            <a:ext cx="2103120" cy="0"/>
+          </a:xfrm>
+          <a:prstGeom prst="line">
+            <a:avLst/>
+          </a:prstGeom>
+          <a:noFill/>
+          <a:ln w="17780">
+            <a:solidFill>
+              <a:srgbClr val="CBD8ED"/>
+            </a:solidFill>
+            <a:prstDash val="solid"/>
+            <a:headEnd type="none"/>
+            <a:tailEnd type="triangle"/>
+          </a:ln>
+        </p:spPr>
+      </p:sp>
+      <p:sp>
+        <p:nvSpPr>
+          <p:cNvPr id="31" name="Text 29"/>
+          <p:cNvSpPr txBox="1"/>
+          <p:nvPr/>
+        </p:nvSpPr>
+        <p:spPr>
+          <a:xfrm>
+            <a:off x="6108192" y="4919472"/>
+            <a:ext cx="2487168" cy="256032"/>
+          </a:xfrm>
+          <a:prstGeom prst="rect">
+            <a:avLst/>
+          </a:prstGeom>
+          <a:noFill/>
+          <a:ln/>
+        </p:spPr>
+        <p:txBody>
+          <a:bodyPr wrap="square" lIns="0" tIns="0" rIns="0" bIns="0" rtlCol="0" anchor="ctr">
+            <a:normAutofit/>
+          </a:bodyPr>
+          <a:lstStyle/>
+          <a:p>
+            <a:pPr algn="l" indent="0" marL="0">
+              <a:lnSpc>
+                <a:spcPct val="100000"/>
+              </a:lnSpc>
+              <a:buNone/>
+            </a:pPr>
+            <a:r>
+              <a:rPr lang="en-US" sz="1050" b="1" dirty="0">
+                <a:solidFill>
+                  <a:srgbClr val="11284C"/>
+                </a:solidFill>
+                <a:latin typeface="Aptos" pitchFamily="34" charset="0"/>
+                <a:ea typeface="Aptos" pitchFamily="34" charset="-122"/>
+                <a:cs typeface="Aptos" pitchFamily="34" charset="-120"/>
+              </a:rPr>
+              <a:t>CỨNG HÓA</a:t>
+            </a:r>
+            <a:endParaRPr lang="en-US" sz="1050" dirty="0"/>
+          </a:p>
+        </p:txBody>
+      </p:sp>
+      <p:sp>
+        <p:nvSpPr>
+          <p:cNvPr id="32" name="Text 30"/>
+          <p:cNvSpPr txBox="1"/>
+          <p:nvPr/>
+        </p:nvSpPr>
+        <p:spPr>
+          <a:xfrm>
+            <a:off x="6108192" y="5294376"/>
+            <a:ext cx="2487168" cy="658368"/>
+          </a:xfrm>
+          <a:prstGeom prst="rect">
+            <a:avLst/>
+          </a:prstGeom>
+          <a:noFill/>
+          <a:ln/>
+        </p:spPr>
+        <p:txBody>
+          <a:bodyPr wrap="square" lIns="0" tIns="0" rIns="0" bIns="0" rtlCol="0" anchor="t">
+            <a:normAutofit/>
+          </a:bodyPr>
+          <a:lstStyle/>
+          <a:p>
+            <a:pPr algn="l" indent="0" marL="0">
+              <a:lnSpc>
+                <a:spcPct val="100000"/>
+              </a:lnSpc>
+              <a:buNone/>
+            </a:pPr>
+            <a:r>
+              <a:rPr lang="en-US" sz="1020" dirty="0">
+                <a:solidFill>
+                  <a:srgbClr val="667792"/>
+                </a:solidFill>
+                <a:latin typeface="Aptos" pitchFamily="34" charset="0"/>
+                <a:ea typeface="Aptos" pitchFamily="34" charset="-122"/>
+                <a:cs typeface="Aptos" pitchFamily="34" charset="-120"/>
+              </a:rPr>
+              <a:t>Monitoring, audit log, backup, privacy &amp; security review</a:t>
+            </a:r>
+            <a:endParaRPr lang="en-US" sz="1020" dirty="0"/>
+          </a:p>
+        </p:txBody>
+      </p:sp>
+      <p:sp>
+        <p:nvSpPr>
+          <p:cNvPr id="33" name="Shape 31"/>
+          <p:cNvSpPr/>
+          <p:nvPr/>
+        </p:nvSpPr>
+        <p:spPr>
+          <a:xfrm>
+            <a:off x="8897112" y="4315968"/>
+            <a:ext cx="429768" cy="429768"/>
+          </a:xfrm>
+          <a:prstGeom prst="ellipse">
+            <a:avLst/>
+          </a:prstGeom>
+          <a:solidFill>
+            <a:srgbClr val="2C9A83"/>
+          </a:solidFill>
+          <a:ln w="12700">
+            <a:solidFill>
+              <a:srgbClr val="2C9A83"/>
+            </a:solidFill>
+            <a:prstDash val="solid"/>
+          </a:ln>
+        </p:spPr>
+      </p:sp>
+      <p:sp>
+        <p:nvSpPr>
+          <p:cNvPr id="34" name="Text 32"/>
+          <p:cNvSpPr txBox="1"/>
+          <p:nvPr/>
+        </p:nvSpPr>
+        <p:spPr>
+          <a:xfrm>
+            <a:off x="8897112" y="4343400"/>
+            <a:ext cx="429768" cy="310896"/>
+          </a:xfrm>
+          <a:prstGeom prst="rect">
+            <a:avLst/>
+          </a:prstGeom>
+          <a:noFill/>
+          <a:ln/>
+        </p:spPr>
+        <p:txBody>
+          <a:bodyPr wrap="square" lIns="0" tIns="0" rIns="0" bIns="0" rtlCol="0" anchor="ctr">
+            <a:normAutofit/>
+          </a:bodyPr>
+          <a:lstStyle/>
+          <a:p>
+            <a:pPr algn="ctr" indent="0" marL="0">
+              <a:lnSpc>
+                <a:spcPct val="100000"/>
+              </a:lnSpc>
+              <a:buNone/>
+            </a:pPr>
+            <a:r>
+              <a:rPr lang="en-US" sz="920" b="1" dirty="0">
+                <a:solidFill>
+                  <a:srgbClr val="FFFFFF"/>
+                </a:solidFill>
+                <a:latin typeface="Aptos" pitchFamily="34" charset="0"/>
+                <a:ea typeface="Aptos" pitchFamily="34" charset="-122"/>
+                <a:cs typeface="Aptos" pitchFamily="34" charset="-120"/>
+              </a:rPr>
+              <a:t>04</a:t>
+            </a:r>
+            <a:endParaRPr lang="en-US" sz="920" dirty="0"/>
+          </a:p>
+        </p:txBody>
+      </p:sp>
+      <p:sp>
+        <p:nvSpPr>
+          <p:cNvPr id="35" name="Text 33"/>
+          <p:cNvSpPr txBox="1"/>
+          <p:nvPr/>
+        </p:nvSpPr>
+        <p:spPr>
+          <a:xfrm>
+            <a:off x="8897112" y="4919472"/>
+            <a:ext cx="2487168" cy="256032"/>
+          </a:xfrm>
+          <a:prstGeom prst="rect">
+            <a:avLst/>
+          </a:prstGeom>
+          <a:noFill/>
+          <a:ln/>
+        </p:spPr>
+        <p:txBody>
+          <a:bodyPr wrap="square" lIns="0" tIns="0" rIns="0" bIns="0" rtlCol="0" anchor="ctr">
+            <a:normAutofit/>
+          </a:bodyPr>
+          <a:lstStyle/>
+          <a:p>
+            <a:pPr algn="l" indent="0" marL="0">
+              <a:lnSpc>
+                <a:spcPct val="100000"/>
+              </a:lnSpc>
+              <a:buNone/>
+            </a:pPr>
+            <a:r>
+              <a:rPr lang="en-US" sz="1050" b="1" dirty="0">
+                <a:solidFill>
+                  <a:srgbClr val="2C9A83"/>
+                </a:solidFill>
+                <a:latin typeface="Aptos" pitchFamily="34" charset="0"/>
+                <a:ea typeface="Aptos" pitchFamily="34" charset="-122"/>
+                <a:cs typeface="Aptos" pitchFamily="34" charset="-120"/>
+              </a:rPr>
+              <a:t>MỞ RỘNG</a:t>
+            </a:r>
+            <a:endParaRPr lang="en-US" sz="1050" dirty="0"/>
+          </a:p>
+        </p:txBody>
+      </p:sp>
+      <p:sp>
+        <p:nvSpPr>
+          <p:cNvPr id="36" name="Text 34"/>
+          <p:cNvSpPr txBox="1"/>
+          <p:nvPr/>
+        </p:nvSpPr>
+        <p:spPr>
+          <a:xfrm>
+            <a:off x="8897112" y="5294376"/>
+            <a:ext cx="2487168" cy="658368"/>
+          </a:xfrm>
+          <a:prstGeom prst="rect">
+            <a:avLst/>
+          </a:prstGeom>
+          <a:noFill/>
+          <a:ln/>
+        </p:spPr>
+        <p:txBody>
+          <a:bodyPr wrap="square" lIns="0" tIns="0" rIns="0" bIns="0" rtlCol="0" anchor="t">
+            <a:normAutofit/>
+          </a:bodyPr>
+          <a:lstStyle/>
+          <a:p>
+            <a:pPr algn="l" indent="0" marL="0">
+              <a:lnSpc>
+                <a:spcPct val="100000"/>
+              </a:lnSpc>
+              <a:buNone/>
+            </a:pPr>
+            <a:r>
+              <a:rPr lang="en-US" sz="1020" dirty="0">
+                <a:solidFill>
+                  <a:srgbClr val="667792"/>
+                </a:solidFill>
+                <a:latin typeface="Aptos" pitchFamily="34" charset="0"/>
+                <a:ea typeface="Aptos" pitchFamily="34" charset="-122"/>
+                <a:cs typeface="Aptos" pitchFamily="34" charset="-120"/>
+              </a:rPr>
+              <a:t>OCR tốt hơn, cá nhân hóa bệnh nền, mô hình B2B2C</a:t>
+            </a:r>
+            <a:endParaRPr lang="en-US" sz="1020" dirty="0"/>
+          </a:p>
+        </p:txBody>
+      </p:sp>
+      <p:sp>
+        <p:nvSpPr>
+          <p:cNvPr id="25" name="Slide Number Placeholder 0"/>
+          <p:cNvSpPr>
+            <a:spLocks noGrp="1"/>
+          </p:cNvSpPr>
+          <p:nvPr>
+            <p:ph type="sldNum" sz="quarter" idx="4294967295"/>
+          </p:nvPr>
+        </p:nvSpPr>
+        <p:spPr>
+          <a:xfrm>
+            <a:off x="11155680" y="6473952"/>
+            <a:ext cx="502920" cy="201168"/>
+          </a:xfrm>
+          <a:prstGeom prst="rect">
+            <a:avLst/>
+          </a:prstGeom>
+          <a:extLst>
+            <a:ext uri="{C572A759-6A51-4108-AA02-DFA0A04FC94B}">
+              <ma14:wrappingTextBoxFlag xmlns:ma14="http://schemas.microsoft.com/office/mac/drawingml/2011/main" val="0"/>
+            </a:ext>
+          </a:extLst>
+        </p:spPr>
+        <p:txBody>
+          <a:bodyPr lIns="0" tIns="0" rIns="0" bIns="0"/>
+          <a:lstStyle>
+            <a:lvl1pPr>
+              <a:defRPr sz="800">
+                <a:solidFill>
+                  <a:srgbClr val="73829E"/>
+                </a:solidFill>
+                <a:latin typeface="Aptos"/>
+                <a:ea typeface="Aptos"/>
+                <a:cs typeface="Aptos"/>
+              </a:defRPr>
+            </a:lvl1pPr>
+          </a:lstStyle>
+          <a:p>
+            <a:pPr algn="r"/>
+            <a:fld id="{F7021451-1387-4CA6-816F-3879F97B5CBC}" type="slidenum">
+              <a:rPr b="0" lang="en-US"/>
+              <a:t>12</a:t>
+            </a:fld>
+            <a:endParaRPr lang="en-US"/>
+          </a:p>
+        </p:txBody>
+      </p:sp>
+    </p:spTree>
+  </p:cSld>
+  <p:clrMapOvr>
+    <a:masterClrMapping/>
+  </p:clrMapOvr>
+</p:sld>
+</file>
+
+<file path=ppt/slides/slide13.xml><?xml version="1.0" encoding="utf-8"?>
+<p:sld xmlns:a="http://schemas.openxmlformats.org/drawingml/2006/main" xmlns:r="http://schemas.openxmlformats.org/officeDocument/2006/relationships" xmlns:p="http://schemas.openxmlformats.org/presentationml/2006/main">
+  <p:cSld name="Slide 13">
     <p:bg>
       <p:bgPr>
         <a:solidFill>
@@ -7073,7 +9107,7 @@
             <a:pPr algn="r"/>
             <a:fld id="{F7021451-1387-4CA6-816F-3879F97B5CBC}" type="slidenum">
               <a:rPr b="0" lang="en-US"/>
-              <a:t>12</a:t>
+              <a:t>13</a:t>
             </a:fld>
             <a:endParaRPr lang="en-US"/>
           </a:p>
@@ -12062,7 +14096,7 @@
       </p:sp>
       <p:pic>
         <p:nvPicPr>
-          <p:cNvPr id="6" name="Image 0" descr="C:\Users\admin\Documents\AITHUCHIEN\P-005\docs\screenshots\landing-page.png">    </p:cNvPr>
+          <p:cNvPr id="6" name="Image 0" descr="C:\Users\Quan\Documents\AIthucchien\Projects\P-005\docs\screenshots\landing-page.png">    </p:cNvPr>
           <p:cNvPicPr>
             <a:picLocks noChangeAspect="1"/>
           </p:cNvPicPr>
@@ -12738,7 +14772,7 @@
       </p:sp>
       <p:pic>
         <p:nvPicPr>
-          <p:cNvPr id="6" name="Image 0" descr="C:\Users\admin\Documents\AITHUCHIEN\P-005\docs\screenshots\interaction-result.png">    </p:cNvPr>
+          <p:cNvPr id="6" name="Image 0" descr="C:\Users\Quan\Documents\AIthucchien\Projects\P-005\docs\screenshots\interaction-result.png">    </p:cNvPr>
           <p:cNvPicPr>
             <a:picLocks noChangeAspect="1"/>
           </p:cNvPicPr>
@@ -13454,7 +15488,7 @@
       </p:sp>
       <p:pic>
         <p:nvPicPr>
-          <p:cNvPr id="6" name="Image 0" descr="C:\Users\admin\Documents\AITHUCHIEN\P-005\docs\screenshots\patient-dashboard.png">    </p:cNvPr>
+          <p:cNvPr id="6" name="Image 0" descr="C:\Users\Quan\Documents\AIthucchien\Projects\P-005\docs\screenshots\patient-dashboard.png">    </p:cNvPr>
           <p:cNvPicPr>
             <a:picLocks noChangeAspect="1"/>
           </p:cNvPicPr>
@@ -13505,7 +15539,7 @@
       </p:sp>
       <p:pic>
         <p:nvPicPr>
-          <p:cNvPr id="8" name="Image 1" descr="C:\Users\admin\Documents\AITHUCHIEN\P-005\docs\screenshots\pharmacist-dashboard.png">    </p:cNvPr>
+          <p:cNvPr id="8" name="Image 1" descr="C:\Users\Quan\Documents\AIthucchien\Projects\P-005\docs\screenshots\pharmacist-dashboard.png">    </p:cNvPr>
           <p:cNvPicPr>
             <a:picLocks noChangeAspect="1"/>
           </p:cNvPicPr>
@@ -18051,7 +20085,7 @@
                 <a:ea typeface="Aptos" pitchFamily="34" charset="-122"/>
                 <a:cs typeface="Aptos" pitchFamily="34" charset="-120"/>
               </a:rPr>
-              <a:t>1.503 thuốc</a:t>
+              <a:t>1.939 hoạt chất</a:t>
             </a:r>
             <a:endParaRPr lang="en-US" sz="1010" dirty="0"/>
           </a:p>
@@ -18071,7 +20105,7 @@
                 <a:ea typeface="Aptos" pitchFamily="34" charset="-122"/>
                 <a:cs typeface="Aptos" pitchFamily="34" charset="-120"/>
               </a:rPr>
-              <a:t>15.140 cặp tương tác</a:t>
+              <a:t>160.227 cặp tương tác</a:t>
             </a:r>
             <a:endParaRPr lang="en-US" sz="1010" dirty="0"/>
           </a:p>

</xml_diff>